<commit_message>
Add deployment safety insight and clickable evidence links to slides
</commit_message>
<xml_diff>
--- a/outputs/CAR_bench_presentation_corrected_first3.pptx
+++ b/outputs/CAR_bench_presentation_corrected_first3.pptx
@@ -30,6 +30,7 @@
     <p:sldId id="278" r:id="rIdReplication1"/>
     <p:sldId id="279" r:id="rIdReplication2"/>
     <p:sldId id="280" r:id="rIdReplication3"/>
+    <p:sldId id="282" r:id="rIdSafetyInsight"/>
     <p:sldId id="276" r:id="rId22"/>
     <p:sldId id="277" r:id="rId23"/>
     <p:sldId id="281" r:id="rIdReplication4"/>
@@ -6105,6 +6106,1157 @@
 </c:chartSpace>
 </file>
 
+<file path=ppt/safety-insight/ppt/notesMasters/notesMaster1.xml><?xml version="1.0" encoding="utf-8"?>
+<p:notesMaster xmlns:p="http://schemas.openxmlformats.org/presentationml/2006/main">
+  <p:cSld>
+    <p:bg>
+      <p:bgRef idx="1001">
+        <a:schemeClr xmlns:a="http://schemas.openxmlformats.org/drawingml/2006/main" val="bg1"/>
+      </p:bgRef>
+    </p:bg>
+    <p:spTree>
+      <p:nvGrpSpPr>
+        <p:cNvPr id="1" name=""/>
+        <p:cNvGrpSpPr/>
+        <p:nvPr/>
+      </p:nvGrpSpPr>
+      <p:grpSpPr>
+        <a:xfrm xmlns:a="http://schemas.openxmlformats.org/drawingml/2006/main"/>
+      </p:grpSpPr>
+      <p:sp>
+        <p:nvSpPr>
+          <p:cNvPr id="2" name="Header Placeholder"/>
+          <p:cNvSpPr/>
+          <p:nvPr>
+            <p:ph type="hdr" sz="quarter"/>
+          </p:nvPr>
+        </p:nvSpPr>
+        <p:spPr>
+          <a:prstGeom xmlns:a="http://schemas.openxmlformats.org/drawingml/2006/main" prst="rect">
+            <a:avLst/>
+          </a:prstGeom>
+        </p:spPr>
+        <p:txBody>
+          <a:bodyPr xmlns:a="http://schemas.openxmlformats.org/drawingml/2006/main"/>
+          <a:lstStyle xmlns:a="http://schemas.openxmlformats.org/drawingml/2006/main"/>
+          <a:p xmlns:a="http://schemas.openxmlformats.org/drawingml/2006/main"/>
+        </p:txBody>
+      </p:sp>
+      <p:sp>
+        <p:nvSpPr>
+          <p:cNvPr id="3" name="Date Placeholder"/>
+          <p:cNvSpPr/>
+          <p:nvPr>
+            <p:ph type="dt" sz="quarter" idx="1"/>
+          </p:nvPr>
+        </p:nvSpPr>
+        <p:spPr>
+          <a:prstGeom xmlns:a="http://schemas.openxmlformats.org/drawingml/2006/main" prst="rect">
+            <a:avLst/>
+          </a:prstGeom>
+        </p:spPr>
+        <p:txBody>
+          <a:bodyPr xmlns:a="http://schemas.openxmlformats.org/drawingml/2006/main"/>
+          <a:lstStyle xmlns:a="http://schemas.openxmlformats.org/drawingml/2006/main"/>
+          <a:p xmlns:a="http://schemas.openxmlformats.org/drawingml/2006/main"/>
+        </p:txBody>
+      </p:sp>
+      <p:sp>
+        <p:nvSpPr>
+          <p:cNvPr id="4" name="Slide Image Placeholder"/>
+          <p:cNvSpPr/>
+          <p:nvPr>
+            <p:ph type="sldImg" idx="2"/>
+          </p:nvPr>
+        </p:nvSpPr>
+        <p:spPr>
+          <a:prstGeom xmlns:a="http://schemas.openxmlformats.org/drawingml/2006/main" prst="rect">
+            <a:avLst/>
+          </a:prstGeom>
+        </p:spPr>
+        <p:txBody>
+          <a:bodyPr xmlns:a="http://schemas.openxmlformats.org/drawingml/2006/main"/>
+          <a:lstStyle xmlns:a="http://schemas.openxmlformats.org/drawingml/2006/main"/>
+          <a:p xmlns:a="http://schemas.openxmlformats.org/drawingml/2006/main"/>
+        </p:txBody>
+      </p:sp>
+      <p:sp>
+        <p:nvSpPr>
+          <p:cNvPr id="5" name="Notes Placeholder"/>
+          <p:cNvSpPr/>
+          <p:nvPr>
+            <p:ph type="body" sz="quarter" idx="3"/>
+          </p:nvPr>
+        </p:nvSpPr>
+        <p:spPr>
+          <a:prstGeom xmlns:a="http://schemas.openxmlformats.org/drawingml/2006/main" prst="rect">
+            <a:avLst/>
+          </a:prstGeom>
+        </p:spPr>
+        <p:txBody>
+          <a:bodyPr xmlns:a="http://schemas.openxmlformats.org/drawingml/2006/main"/>
+          <a:lstStyle xmlns:a="http://schemas.openxmlformats.org/drawingml/2006/main"/>
+          <a:p xmlns:a="http://schemas.openxmlformats.org/drawingml/2006/main"/>
+        </p:txBody>
+      </p:sp>
+      <p:sp>
+        <p:nvSpPr>
+          <p:cNvPr id="6" name="Footer Placeholder"/>
+          <p:cNvSpPr/>
+          <p:nvPr>
+            <p:ph type="ftr" sz="quarter" idx="4"/>
+          </p:nvPr>
+        </p:nvSpPr>
+        <p:spPr>
+          <a:prstGeom xmlns:a="http://schemas.openxmlformats.org/drawingml/2006/main" prst="rect">
+            <a:avLst/>
+          </a:prstGeom>
+        </p:spPr>
+        <p:txBody>
+          <a:bodyPr xmlns:a="http://schemas.openxmlformats.org/drawingml/2006/main"/>
+          <a:lstStyle xmlns:a="http://schemas.openxmlformats.org/drawingml/2006/main"/>
+          <a:p xmlns:a="http://schemas.openxmlformats.org/drawingml/2006/main"/>
+        </p:txBody>
+      </p:sp>
+      <p:sp>
+        <p:nvSpPr>
+          <p:cNvPr id="7" name="Slide Number Placeholder"/>
+          <p:cNvSpPr/>
+          <p:nvPr>
+            <p:ph type="sldNum" sz="quarter" idx="5"/>
+          </p:nvPr>
+        </p:nvSpPr>
+        <p:spPr>
+          <a:prstGeom xmlns:a="http://schemas.openxmlformats.org/drawingml/2006/main" prst="rect">
+            <a:avLst/>
+          </a:prstGeom>
+        </p:spPr>
+        <p:txBody>
+          <a:bodyPr xmlns:a="http://schemas.openxmlformats.org/drawingml/2006/main"/>
+          <a:lstStyle xmlns:a="http://schemas.openxmlformats.org/drawingml/2006/main"/>
+          <a:p xmlns:a="http://schemas.openxmlformats.org/drawingml/2006/main"/>
+        </p:txBody>
+      </p:sp>
+    </p:spTree>
+  </p:cSld>
+  <p:clrMap bg1="lt1" tx1="dk1" bg2="lt2" tx2="dk2" accent1="accent1" accent2="accent2" accent3="accent3" accent4="accent4" accent5="accent5" accent6="accent6" hlink="hlink" folHlink="folHlink"/>
+  <p:notesStyle>
+    <a:lvl1pPr xmlns:a="http://schemas.openxmlformats.org/drawingml/2006/main" marL="0" algn="l" defTabSz="914400" rtl="0" eaLnBrk="1" latinLnBrk="0" hangingPunct="1">
+      <a:defRPr sz="1200" kern="1200"/>
+    </a:lvl1pPr>
+  </p:notesStyle>
+</p:notesMaster>
+</file>
+
+<file path=ppt/safety-insight/ppt/notesMasters/theme/theme3.xml><?xml version="1.0" encoding="utf-8"?>
+<a:theme xmlns:a="http://schemas.openxmlformats.org/drawingml/2006/main" name="Office Theme">
+  <a:themeElements>
+    <a:clrScheme name="Office">
+      <a:dk1>
+        <a:srgbClr val="000000"/>
+      </a:dk1>
+      <a:lt1>
+        <a:srgbClr val="FFFFFF"/>
+      </a:lt1>
+      <a:dk2>
+        <a:srgbClr val="44546A"/>
+      </a:dk2>
+      <a:lt2>
+        <a:srgbClr val="E7E6E6"/>
+      </a:lt2>
+      <a:accent1>
+        <a:srgbClr val="4472C4"/>
+      </a:accent1>
+      <a:accent2>
+        <a:srgbClr val="ED7D31"/>
+      </a:accent2>
+      <a:accent3>
+        <a:srgbClr val="A5A5A5"/>
+      </a:accent3>
+      <a:accent4>
+        <a:srgbClr val="FFC000"/>
+      </a:accent4>
+      <a:accent5>
+        <a:srgbClr val="5B9BD5"/>
+      </a:accent5>
+      <a:accent6>
+        <a:srgbClr val="70AD47"/>
+      </a:accent6>
+      <a:hlink>
+        <a:srgbClr val="0563C1"/>
+      </a:hlink>
+      <a:folHlink>
+        <a:srgbClr val="954F72"/>
+      </a:folHlink>
+    </a:clrScheme>
+    <a:fontScheme name="Office">
+      <a:majorFont>
+        <a:latin typeface="Aptos Display"/>
+        <a:ea typeface=""/>
+        <a:cs typeface=""/>
+      </a:majorFont>
+      <a:minorFont>
+        <a:latin typeface="Aptos"/>
+        <a:ea typeface=""/>
+        <a:cs typeface=""/>
+      </a:minorFont>
+    </a:fontScheme>
+    <a:fmtScheme name="Office">
+      <a:fillStyleLst>
+        <a:solidFill>
+          <a:schemeClr val="phClr"/>
+        </a:solidFill>
+        <a:gradFill>
+          <a:gsLst>
+            <a:gs pos="0">
+              <a:schemeClr val="phClr">
+                <a:tint val="67000"/>
+                <a:lumMod val="110000"/>
+              </a:schemeClr>
+            </a:gs>
+            <a:gs pos="50000">
+              <a:schemeClr val="phClr">
+                <a:tint val="73000"/>
+                <a:lumMod val="105000"/>
+              </a:schemeClr>
+            </a:gs>
+            <a:gs pos="100000">
+              <a:schemeClr val="phClr">
+                <a:tint val="81000"/>
+                <a:lumMod val="105000"/>
+              </a:schemeClr>
+            </a:gs>
+          </a:gsLst>
+          <a:lin ang="5400000" scaled="0"/>
+          <a:tileRect/>
+        </a:gradFill>
+        <a:gradFill>
+          <a:gsLst>
+            <a:gs pos="0">
+              <a:schemeClr val="phClr">
+                <a:tint val="94000"/>
+                <a:lumMod val="102000"/>
+              </a:schemeClr>
+            </a:gs>
+            <a:gs pos="50000">
+              <a:schemeClr val="phClr">
+                <a:shade val="100000"/>
+                <a:lumMod val="100000"/>
+              </a:schemeClr>
+            </a:gs>
+            <a:gs pos="100000">
+              <a:schemeClr val="phClr">
+                <a:shade val="78000"/>
+                <a:lumMod val="99000"/>
+              </a:schemeClr>
+            </a:gs>
+          </a:gsLst>
+          <a:lin ang="5400000" scaled="0"/>
+          <a:tileRect/>
+        </a:gradFill>
+      </a:fillStyleLst>
+      <a:lnStyleLst>
+        <a:ln w="6350">
+          <a:prstDash val="solid"/>
+        </a:ln>
+        <a:ln w="12700">
+          <a:prstDash val="solid"/>
+        </a:ln>
+        <a:ln w="19050">
+          <a:prstDash val="solid"/>
+        </a:ln>
+      </a:lnStyleLst>
+      <a:effectStyleLst>
+        <a:effectStyle>
+          <a:effectLst/>
+        </a:effectStyle>
+        <a:effectStyle>
+          <a:effectLst/>
+        </a:effectStyle>
+        <a:effectStyle>
+          <a:effectLst/>
+        </a:effectStyle>
+      </a:effectStyleLst>
+      <a:bgFillStyleLst>
+        <a:solidFill>
+          <a:schemeClr val="phClr"/>
+        </a:solidFill>
+        <a:solidFill>
+          <a:schemeClr val="phClr">
+            <a:tint val="95000"/>
+          </a:schemeClr>
+        </a:solidFill>
+        <a:gradFill>
+          <a:gsLst>
+            <a:gs pos="0">
+              <a:schemeClr val="phClr">
+                <a:tint val="93000"/>
+                <a:shade val="98000"/>
+                <a:lumMod val="102000"/>
+              </a:schemeClr>
+            </a:gs>
+            <a:gs pos="50000">
+              <a:schemeClr val="phClr">
+                <a:tint val="98000"/>
+                <a:shade val="90000"/>
+                <a:lumMod val="103000"/>
+              </a:schemeClr>
+            </a:gs>
+            <a:gs pos="100000">
+              <a:schemeClr val="phClr">
+                <a:shade val="63000"/>
+              </a:schemeClr>
+            </a:gs>
+          </a:gsLst>
+          <a:lin ang="5400000" scaled="0"/>
+          <a:tileRect/>
+        </a:gradFill>
+      </a:bgFillStyleLst>
+    </a:fmtScheme>
+  </a:themeElements>
+</a:theme>
+</file>
+
+<file path=ppt/safety-insight/ppt/notesSlides/notesSlide1.xml><?xml version="1.0" encoding="utf-8"?>
+<p:notes xmlns:p="http://schemas.openxmlformats.org/presentationml/2006/main">
+  <p:cSld>
+    <p:spTree>
+      <p:nvGrpSpPr>
+        <p:cNvPr id="1" name=""/>
+        <p:cNvGrpSpPr/>
+        <p:nvPr/>
+      </p:nvGrpSpPr>
+      <p:grpSpPr>
+        <a:xfrm xmlns:a="http://schemas.openxmlformats.org/drawingml/2006/main"/>
+      </p:grpSpPr>
+      <p:sp>
+        <p:nvSpPr>
+          <p:cNvPr id="2" name="Slide Image Placeholder 1"/>
+          <p:cNvSpPr>
+            <a:spLocks xmlns:a="http://schemas.openxmlformats.org/drawingml/2006/main" noGrp="1"/>
+          </p:cNvSpPr>
+          <p:nvPr>
+            <p:ph type="sldImg" idx="0"/>
+          </p:nvPr>
+        </p:nvSpPr>
+        <p:spPr/>
+      </p:sp>
+      <p:sp>
+        <p:nvSpPr>
+          <p:cNvPr id="3" name="Notes Placeholder 2"/>
+          <p:cNvSpPr>
+            <a:spLocks xmlns:a="http://schemas.openxmlformats.org/drawingml/2006/main" noGrp="1"/>
+          </p:cNvSpPr>
+          <p:nvPr>
+            <p:ph type="body" idx="1"/>
+          </p:nvPr>
+        </p:nvSpPr>
+        <p:spPr/>
+        <p:txBody>
+          <a:bodyPr xmlns:a="http://schemas.openxmlformats.org/drawingml/2006/main"/>
+          <a:lstStyle xmlns:a="http://schemas.openxmlformats.org/drawingml/2006/main"/>
+          <a:p xmlns:a="http://schemas.openxmlformats.org/drawingml/2006/main">
+            <a:pPr indent="0">
+              <a:lnSpc>
+                <a:spcPct val="100000"/>
+              </a:lnSpc>
+              <a:buNone/>
+            </a:pPr>
+            <a:r>
+              <a:rPr sz="2000" b="0" u="none" strike="noStrike">
+                <a:solidFill>
+                  <a:srgbClr val="000000"/>
+                </a:solidFill>
+                <a:latin typeface="Arial"/>
+                <a:ea typeface="Arial"/>
+                <a:cs typeface="Arial"/>
+              </a:rPr>
+              <a:t>This slide expresses the group's deployment recommendation, not a measured CAR-bench result or an automotive certification claim. The 1% example is hypothetical; benchmark failure rates are not unsafe-action rates. The powered-door-release example illustrates an agent-accessible command: an independent controller must enforce a motion interlock using trusted vehicle-state signals at execution time, regardless of the model's interpretation or claimed approval. This does not propose disabling mechanical emergency egress. Emergency handling needs a separately engineered and validated path. Fixed rules alone do not guarantee safety: sensors, controller logic, fault handling and actuator integration still require engineering and validation. No new interlock mechanism was evaluated in our replication. The benchmark tool snapshot includes trunk-door operations, but this passenger-door illustration is not asserted to be an existing benchmark policy or trial. The empirical motivation is persistent inconsistency (Disambiguation first-three Pass@3 80%, Pass^3 40%), not a measured probability of opening a moving vehicle's door. Repository: https://github.com/victorcao1104/car-bench-gpt6-luna-reproduction . English report: https://github.com/victorcao1104/car-bench-gpt6-luna-reproduction/blob/main/outputs/extension/CAR-bench_Corrected_First3_Report_EN.pdf .</a:t>
+            </a:r>
+          </a:p>
+        </p:txBody>
+      </p:sp>
+      <p:sp>
+        <p:nvSpPr>
+          <p:cNvPr id="4" name="Slide Number Placeholder 3"/>
+          <p:cNvSpPr>
+            <a:spLocks xmlns:a="http://schemas.openxmlformats.org/drawingml/2006/main" noGrp="1"/>
+          </p:cNvSpPr>
+          <p:nvPr>
+            <p:ph type="sldNum" idx="5"/>
+          </p:nvPr>
+        </p:nvSpPr>
+        <p:spPr/>
+        <p:txBody>
+          <a:bodyPr xmlns:a="http://schemas.openxmlformats.org/drawingml/2006/main"/>
+          <a:lstStyle xmlns:a="http://schemas.openxmlformats.org/drawingml/2006/main"/>
+          <a:p xmlns:a="http://schemas.openxmlformats.org/drawingml/2006/main"/>
+        </p:txBody>
+      </p:sp>
+    </p:spTree>
+  </p:cSld>
+  <p:clrMapOvr>
+    <a:masterClrMapping xmlns:a="http://schemas.openxmlformats.org/drawingml/2006/main"/>
+  </p:clrMapOvr>
+</p:notes>
+</file>
+
+<file path=ppt/safety-insight/ppt/slideLayouts/slideLayout1.xml><?xml version="1.0" encoding="utf-8"?>
+<p:sldLayout xmlns:p="http://schemas.openxmlformats.org/presentationml/2006/main" type="blank" preserve="1">
+  <p:cSld name="DEFAULT">
+    <p:spTree>
+      <p:nvGrpSpPr>
+        <p:cNvPr id="1" name=""/>
+        <p:cNvGrpSpPr/>
+        <p:nvPr/>
+      </p:nvGrpSpPr>
+      <p:grpSpPr>
+        <a:xfrm xmlns:a="http://schemas.openxmlformats.org/drawingml/2006/main"/>
+      </p:grpSpPr>
+    </p:spTree>
+  </p:cSld>
+</p:sldLayout>
+</file>
+
+<file path=ppt/safety-insight/ppt/slideMasters/slideMaster1.xml><?xml version="1.0" encoding="utf-8"?>
+<p:sldMaster xmlns:p="http://schemas.openxmlformats.org/presentationml/2006/main">
+  <p:cSld>
+    <p:bg>
+      <p:bgPr>
+        <a:solidFill xmlns:a="http://schemas.openxmlformats.org/drawingml/2006/main">
+          <a:srgbClr val="FFFFFF"/>
+        </a:solidFill>
+      </p:bgPr>
+    </p:bg>
+    <p:spTree>
+      <p:nvGrpSpPr>
+        <p:cNvPr id="1" name=""/>
+        <p:cNvGrpSpPr/>
+        <p:nvPr/>
+      </p:nvGrpSpPr>
+      <p:grpSpPr>
+        <a:xfrm xmlns:a="http://schemas.openxmlformats.org/drawingml/2006/main"/>
+      </p:grpSpPr>
+      <p:sp>
+        <p:nvSpPr>
+          <p:cNvPr id="2" name="PlaceHolder 1">
+            <a:extLst xmlns:a="http://schemas.openxmlformats.org/drawingml/2006/main">
+              <a:ext uri="{FF2B5EF4-FFF2-40B4-BE49-F238E27FC236}">
+                <a16:creationId xmlns:a16="http://schemas.microsoft.com/office/drawing/2014/main" id="{E3F79907-6FA1-47CC-8080-1F9B24983CF5}"/>
+              </a:ext>
+            </a:extLst>
+          </p:cNvPr>
+          <p:cNvSpPr>
+            <a:spLocks xmlns:a="http://schemas.openxmlformats.org/drawingml/2006/main" noGrp="1"/>
+          </p:cNvSpPr>
+          <p:nvPr>
+            <p:ph type="title" idx="0"/>
+          </p:nvPr>
+        </p:nvSpPr>
+        <p:spPr>
+          <a:xfrm xmlns:a="http://schemas.openxmlformats.org/drawingml/2006/main">
+            <a:off x="609480" y="273600"/>
+            <a:ext cx="10972440" cy="1144800"/>
+          </a:xfrm>
+          <a:prstGeom xmlns:a="http://schemas.openxmlformats.org/drawingml/2006/main" prst="rect">
+            <a:avLst/>
+          </a:prstGeom>
+          <a:noFill xmlns:a="http://schemas.openxmlformats.org/drawingml/2006/main"/>
+          <a:ln xmlns:a="http://schemas.openxmlformats.org/drawingml/2006/main" w="0">
+            <a:noFill/>
+          </a:ln>
+        </p:spPr>
+        <p:txBody>
+          <a:bodyPr xmlns:a="http://schemas.openxmlformats.org/drawingml/2006/main" lIns="0" tIns="0" rIns="0" bIns="0" anchor="ctr">
+            <a:noAutofit/>
+          </a:bodyPr>
+          <a:lstStyle xmlns:a="http://schemas.openxmlformats.org/drawingml/2006/main"/>
+          <a:p xmlns:a="http://schemas.openxmlformats.org/drawingml/2006/main">
+            <a:pPr indent="0">
+              <a:buNone/>
+            </a:pPr>
+            <a:r>
+              <a:rPr sz="1800" b="0" u="none" strike="noStrike">
+                <a:solidFill>
+                  <a:schemeClr val="dk1"/>
+                </a:solidFill>
+                <a:latin typeface="Aptos"/>
+                <a:ea typeface="Aptos"/>
+                <a:cs typeface="Aptos"/>
+              </a:rPr>
+              <a:t>Click to edit the title text format</a:t>
+            </a:r>
+          </a:p>
+        </p:txBody>
+      </p:sp>
+      <p:sp>
+        <p:nvSpPr>
+          <p:cNvPr id="3" name="PlaceHolder 2">
+            <a:extLst xmlns:a="http://schemas.openxmlformats.org/drawingml/2006/main">
+              <a:ext uri="{FF2B5EF4-FFF2-40B4-BE49-F238E27FC236}">
+                <a16:creationId xmlns:a16="http://schemas.microsoft.com/office/drawing/2014/main" id="{5077C676-03D3-45CA-B97B-E0B390ECD53F}"/>
+              </a:ext>
+            </a:extLst>
+          </p:cNvPr>
+          <p:cNvSpPr>
+            <a:spLocks xmlns:a="http://schemas.openxmlformats.org/drawingml/2006/main" noGrp="1"/>
+          </p:cNvSpPr>
+          <p:nvPr>
+            <p:ph type="body" idx="0"/>
+          </p:nvPr>
+        </p:nvSpPr>
+        <p:spPr>
+          <a:xfrm xmlns:a="http://schemas.openxmlformats.org/drawingml/2006/main">
+            <a:off x="609480" y="1604520"/>
+            <a:ext cx="10972440" cy="3977280"/>
+          </a:xfrm>
+          <a:prstGeom xmlns:a="http://schemas.openxmlformats.org/drawingml/2006/main" prst="rect">
+            <a:avLst/>
+          </a:prstGeom>
+          <a:noFill xmlns:a="http://schemas.openxmlformats.org/drawingml/2006/main"/>
+          <a:ln xmlns:a="http://schemas.openxmlformats.org/drawingml/2006/main" w="0">
+            <a:noFill/>
+          </a:ln>
+        </p:spPr>
+        <p:txBody>
+          <a:bodyPr xmlns:a="http://schemas.openxmlformats.org/drawingml/2006/main" lIns="0" tIns="0" rIns="0" bIns="0" anchor="t">
+            <a:normAutofit/>
+          </a:bodyPr>
+          <a:lstStyle xmlns:a="http://schemas.openxmlformats.org/drawingml/2006/main"/>
+          <a:p xmlns:a="http://schemas.openxmlformats.org/drawingml/2006/main">
+            <a:pPr marL="432000" indent="-324000">
+              <a:spcBef>
+                <a:spcPts val="1417"/>
+              </a:spcBef>
+              <a:buClr>
+                <a:srgbClr val="000000"/>
+              </a:buClr>
+              <a:buSzPct val="45000"/>
+              <a:buFont typeface="Wingdings"/>
+              <a:buChar char=""/>
+            </a:pPr>
+            <a:r>
+              <a:rPr sz="3200" b="0" u="none" strike="noStrike">
+                <a:solidFill>
+                  <a:schemeClr val="dk1"/>
+                </a:solidFill>
+                <a:latin typeface="Aptos"/>
+                <a:ea typeface="Aptos"/>
+                <a:cs typeface="Aptos"/>
+              </a:rPr>
+              <a:t>Click to edit the outline text format</a:t>
+            </a:r>
+          </a:p>
+          <a:p xmlns:a="http://schemas.openxmlformats.org/drawingml/2006/main">
+            <a:pPr marL="864000" lvl="1" indent="-324000">
+              <a:spcBef>
+                <a:spcPts val="1134"/>
+              </a:spcBef>
+              <a:buClr>
+                <a:srgbClr val="000000"/>
+              </a:buClr>
+              <a:buSzPct val="75000"/>
+              <a:buFont typeface="Symbol"/>
+              <a:buChar char=""/>
+            </a:pPr>
+            <a:r>
+              <a:rPr sz="2400" b="0" u="none" strike="noStrike">
+                <a:solidFill>
+                  <a:schemeClr val="dk1"/>
+                </a:solidFill>
+                <a:latin typeface="Aptos"/>
+                <a:ea typeface="Aptos"/>
+                <a:cs typeface="Aptos"/>
+              </a:rPr>
+              <a:t>Second Outline Level</a:t>
+            </a:r>
+          </a:p>
+          <a:p xmlns:a="http://schemas.openxmlformats.org/drawingml/2006/main">
+            <a:pPr marL="1296000" lvl="2" indent="-288000">
+              <a:spcBef>
+                <a:spcPts val="850"/>
+              </a:spcBef>
+              <a:buClr>
+                <a:srgbClr val="000000"/>
+              </a:buClr>
+              <a:buSzPct val="45000"/>
+              <a:buFont typeface="Wingdings"/>
+              <a:buChar char=""/>
+            </a:pPr>
+            <a:r>
+              <a:rPr sz="2000" b="0" u="none" strike="noStrike">
+                <a:solidFill>
+                  <a:schemeClr val="dk1"/>
+                </a:solidFill>
+                <a:latin typeface="Aptos"/>
+                <a:ea typeface="Aptos"/>
+                <a:cs typeface="Aptos"/>
+              </a:rPr>
+              <a:t>Third Outline Level</a:t>
+            </a:r>
+          </a:p>
+          <a:p xmlns:a="http://schemas.openxmlformats.org/drawingml/2006/main">
+            <a:pPr marL="1728000" lvl="3" indent="-216000">
+              <a:spcBef>
+                <a:spcPts val="567"/>
+              </a:spcBef>
+              <a:buClr>
+                <a:srgbClr val="000000"/>
+              </a:buClr>
+              <a:buSzPct val="75000"/>
+              <a:buFont typeface="Symbol"/>
+              <a:buChar char=""/>
+            </a:pPr>
+            <a:r>
+              <a:rPr sz="2000" b="0" u="none" strike="noStrike">
+                <a:solidFill>
+                  <a:schemeClr val="dk1"/>
+                </a:solidFill>
+                <a:latin typeface="Aptos"/>
+                <a:ea typeface="Aptos"/>
+                <a:cs typeface="Aptos"/>
+              </a:rPr>
+              <a:t>Fourth Outline Level</a:t>
+            </a:r>
+          </a:p>
+          <a:p xmlns:a="http://schemas.openxmlformats.org/drawingml/2006/main">
+            <a:pPr marL="2160000" lvl="4" indent="-216000">
+              <a:spcBef>
+                <a:spcPts val="283"/>
+              </a:spcBef>
+              <a:buClr>
+                <a:srgbClr val="000000"/>
+              </a:buClr>
+              <a:buSzPct val="45000"/>
+              <a:buFont typeface="Wingdings"/>
+              <a:buChar char=""/>
+            </a:pPr>
+            <a:r>
+              <a:rPr sz="2000" b="0" u="none" strike="noStrike">
+                <a:solidFill>
+                  <a:schemeClr val="dk1"/>
+                </a:solidFill>
+                <a:latin typeface="Aptos"/>
+                <a:ea typeface="Aptos"/>
+                <a:cs typeface="Aptos"/>
+              </a:rPr>
+              <a:t>Fifth Outline Level</a:t>
+            </a:r>
+          </a:p>
+          <a:p xmlns:a="http://schemas.openxmlformats.org/drawingml/2006/main">
+            <a:pPr marL="2592000" lvl="5" indent="-216000">
+              <a:spcBef>
+                <a:spcPts val="283"/>
+              </a:spcBef>
+              <a:buClr>
+                <a:srgbClr val="000000"/>
+              </a:buClr>
+              <a:buSzPct val="45000"/>
+              <a:buFont typeface="Wingdings"/>
+              <a:buChar char=""/>
+            </a:pPr>
+            <a:r>
+              <a:rPr sz="2000" b="0" u="none" strike="noStrike">
+                <a:solidFill>
+                  <a:schemeClr val="dk1"/>
+                </a:solidFill>
+                <a:latin typeface="Aptos"/>
+                <a:ea typeface="Aptos"/>
+                <a:cs typeface="Aptos"/>
+              </a:rPr>
+              <a:t>Sixth Outline Level</a:t>
+            </a:r>
+          </a:p>
+          <a:p xmlns:a="http://schemas.openxmlformats.org/drawingml/2006/main">
+            <a:pPr marL="3024000" lvl="6" indent="-216000">
+              <a:spcBef>
+                <a:spcPts val="283"/>
+              </a:spcBef>
+              <a:buClr>
+                <a:srgbClr val="000000"/>
+              </a:buClr>
+              <a:buSzPct val="45000"/>
+              <a:buFont typeface="Wingdings"/>
+              <a:buChar char=""/>
+            </a:pPr>
+            <a:r>
+              <a:rPr sz="2000" b="0" u="none" strike="noStrike">
+                <a:solidFill>
+                  <a:schemeClr val="dk1"/>
+                </a:solidFill>
+                <a:latin typeface="Aptos"/>
+                <a:ea typeface="Aptos"/>
+                <a:cs typeface="Aptos"/>
+              </a:rPr>
+              <a:t>Seventh Outline Level</a:t>
+            </a:r>
+          </a:p>
+        </p:txBody>
+      </p:sp>
+    </p:spTree>
+  </p:cSld>
+  <p:clrMap bg1="lt1" tx1="dk1" bg2="lt2" tx2="dk2" accent1="accent1" accent2="accent2" accent3="accent3" accent4="accent4" accent5="accent5" accent6="accent6" hlink="hlink" folHlink="folHlink"/>
+  <p:sldLayoutIdLst>
+    <p:sldLayoutId xmlns:r="http://schemas.openxmlformats.org/officeDocument/2006/relationships" id="2147483649" r:id="Rc2c02fc2b59741e9"/>
+  </p:sldLayoutIdLst>
+  <p:txStyles>
+    <p:titleStyle>
+      <a:lvl1pPr xmlns:a="http://schemas.openxmlformats.org/drawingml/2006/main" algn="l" defTabSz="914400">
+        <a:lnSpc>
+          <a:spcPct val="90000"/>
+        </a:lnSpc>
+        <a:spcBef>
+          <a:spcPct val="0"/>
+        </a:spcBef>
+        <a:buNone/>
+        <a:defRPr sz="4400" kern="1200">
+          <a:solidFill>
+            <a:schemeClr val="tx1"/>
+          </a:solidFill>
+          <a:latin typeface="+mj-lt"/>
+          <a:ea typeface="+mj-lt"/>
+          <a:cs typeface="+mj-lt"/>
+        </a:defRPr>
+      </a:lvl1pPr>
+    </p:titleStyle>
+    <p:bodyStyle>
+      <a:lvl1pPr xmlns:a="http://schemas.openxmlformats.org/drawingml/2006/main" marL="228600" indent="-228600" algn="l" defTabSz="914400">
+        <a:lnSpc>
+          <a:spcPct val="90000"/>
+        </a:lnSpc>
+        <a:spcBef>
+          <a:spcPts val="1000"/>
+        </a:spcBef>
+        <a:buFont typeface="Arial"/>
+        <a:buChar char="•"/>
+        <a:defRPr sz="2800" kern="1200">
+          <a:solidFill>
+            <a:schemeClr val="tx1"/>
+          </a:solidFill>
+          <a:latin typeface="+mn-lt"/>
+          <a:ea typeface="+mn-lt"/>
+          <a:cs typeface="+mn-lt"/>
+        </a:defRPr>
+      </a:lvl1pPr>
+      <a:lvl2pPr xmlns:a="http://schemas.openxmlformats.org/drawingml/2006/main" marL="685800" indent="-228600" algn="l" defTabSz="914400">
+        <a:lnSpc>
+          <a:spcPct val="90000"/>
+        </a:lnSpc>
+        <a:spcBef>
+          <a:spcPts val="500"/>
+        </a:spcBef>
+        <a:buFont typeface="Arial"/>
+        <a:buChar char="•"/>
+        <a:defRPr sz="2400" kern="1200">
+          <a:solidFill>
+            <a:schemeClr val="tx1"/>
+          </a:solidFill>
+          <a:latin typeface="+mn-lt"/>
+          <a:ea typeface="+mn-lt"/>
+          <a:cs typeface="+mn-lt"/>
+        </a:defRPr>
+      </a:lvl2pPr>
+      <a:lvl3pPr xmlns:a="http://schemas.openxmlformats.org/drawingml/2006/main" marL="1143000" indent="-228600" algn="l" defTabSz="914400">
+        <a:lnSpc>
+          <a:spcPct val="90000"/>
+        </a:lnSpc>
+        <a:spcBef>
+          <a:spcPts val="500"/>
+        </a:spcBef>
+        <a:buFont typeface="Arial"/>
+        <a:buChar char="•"/>
+        <a:defRPr sz="2000" kern="1200">
+          <a:solidFill>
+            <a:schemeClr val="tx1"/>
+          </a:solidFill>
+          <a:latin typeface="+mn-lt"/>
+          <a:ea typeface="+mn-lt"/>
+          <a:cs typeface="+mn-lt"/>
+        </a:defRPr>
+      </a:lvl3pPr>
+      <a:lvl4pPr xmlns:a="http://schemas.openxmlformats.org/drawingml/2006/main" marL="1600200" indent="-228600" algn="l" defTabSz="914400">
+        <a:lnSpc>
+          <a:spcPct val="90000"/>
+        </a:lnSpc>
+        <a:spcBef>
+          <a:spcPts val="500"/>
+        </a:spcBef>
+        <a:buFont typeface="Arial"/>
+        <a:buChar char="•"/>
+        <a:defRPr sz="1800" kern="1200">
+          <a:solidFill>
+            <a:schemeClr val="tx1"/>
+          </a:solidFill>
+          <a:latin typeface="+mn-lt"/>
+          <a:ea typeface="+mn-lt"/>
+          <a:cs typeface="+mn-lt"/>
+        </a:defRPr>
+      </a:lvl4pPr>
+      <a:lvl5pPr xmlns:a="http://schemas.openxmlformats.org/drawingml/2006/main" marL="2057400" indent="-228600" algn="l" defTabSz="914400">
+        <a:lnSpc>
+          <a:spcPct val="90000"/>
+        </a:lnSpc>
+        <a:spcBef>
+          <a:spcPts val="500"/>
+        </a:spcBef>
+        <a:buFont typeface="Arial"/>
+        <a:buChar char="•"/>
+        <a:defRPr sz="1800" kern="1200">
+          <a:solidFill>
+            <a:schemeClr val="tx1"/>
+          </a:solidFill>
+          <a:latin typeface="+mn-lt"/>
+          <a:ea typeface="+mn-lt"/>
+          <a:cs typeface="+mn-lt"/>
+        </a:defRPr>
+      </a:lvl5pPr>
+      <a:lvl6pPr xmlns:a="http://schemas.openxmlformats.org/drawingml/2006/main" marL="2514600" indent="-228600" algn="l" defTabSz="914400">
+        <a:lnSpc>
+          <a:spcPct val="90000"/>
+        </a:lnSpc>
+        <a:spcBef>
+          <a:spcPts val="500"/>
+        </a:spcBef>
+        <a:buFont typeface="Arial"/>
+        <a:buChar char="•"/>
+        <a:defRPr sz="1800" kern="1200">
+          <a:solidFill>
+            <a:schemeClr val="tx1"/>
+          </a:solidFill>
+          <a:latin typeface="+mn-lt"/>
+          <a:ea typeface="+mn-lt"/>
+          <a:cs typeface="+mn-lt"/>
+        </a:defRPr>
+      </a:lvl6pPr>
+      <a:lvl7pPr xmlns:a="http://schemas.openxmlformats.org/drawingml/2006/main" marL="2971800" indent="-228600" algn="l" defTabSz="914400">
+        <a:lnSpc>
+          <a:spcPct val="90000"/>
+        </a:lnSpc>
+        <a:spcBef>
+          <a:spcPts val="500"/>
+        </a:spcBef>
+        <a:buFont typeface="Arial"/>
+        <a:buChar char="•"/>
+        <a:defRPr sz="1800" kern="1200">
+          <a:solidFill>
+            <a:schemeClr val="tx1"/>
+          </a:solidFill>
+          <a:latin typeface="+mn-lt"/>
+          <a:ea typeface="+mn-lt"/>
+          <a:cs typeface="+mn-lt"/>
+        </a:defRPr>
+      </a:lvl7pPr>
+      <a:lvl8pPr xmlns:a="http://schemas.openxmlformats.org/drawingml/2006/main" marL="3429000" indent="-228600" algn="l" defTabSz="914400">
+        <a:lnSpc>
+          <a:spcPct val="90000"/>
+        </a:lnSpc>
+        <a:spcBef>
+          <a:spcPts val="500"/>
+        </a:spcBef>
+        <a:buFont typeface="Arial"/>
+        <a:buChar char="•"/>
+        <a:defRPr sz="1800" kern="1200">
+          <a:solidFill>
+            <a:schemeClr val="tx1"/>
+          </a:solidFill>
+          <a:latin typeface="+mn-lt"/>
+          <a:ea typeface="+mn-lt"/>
+          <a:cs typeface="+mn-lt"/>
+        </a:defRPr>
+      </a:lvl8pPr>
+      <a:lvl9pPr xmlns:a="http://schemas.openxmlformats.org/drawingml/2006/main" marL="3886200" indent="-228600" algn="l" defTabSz="914400">
+        <a:lnSpc>
+          <a:spcPct val="90000"/>
+        </a:lnSpc>
+        <a:spcBef>
+          <a:spcPts val="500"/>
+        </a:spcBef>
+        <a:buFont typeface="Arial"/>
+        <a:buChar char="•"/>
+        <a:defRPr sz="1800" kern="1200">
+          <a:solidFill>
+            <a:schemeClr val="tx1"/>
+          </a:solidFill>
+          <a:latin typeface="+mn-lt"/>
+          <a:ea typeface="+mn-lt"/>
+          <a:cs typeface="+mn-lt"/>
+        </a:defRPr>
+      </a:lvl9pPr>
+    </p:bodyStyle>
+    <p:otherStyle>
+      <a:lvl1pPr xmlns:a="http://schemas.openxmlformats.org/drawingml/2006/main" marL="0" algn="l" defTabSz="914400">
+        <a:buNone/>
+        <a:defRPr sz="1800" kern="1200">
+          <a:solidFill>
+            <a:schemeClr val="tx1"/>
+          </a:solidFill>
+          <a:latin typeface="+mn-lt"/>
+          <a:ea typeface="+mn-lt"/>
+          <a:cs typeface="+mn-lt"/>
+        </a:defRPr>
+      </a:lvl1pPr>
+      <a:lvl2pPr xmlns:a="http://schemas.openxmlformats.org/drawingml/2006/main" marL="457200" algn="l" defTabSz="914400">
+        <a:buNone/>
+        <a:defRPr sz="1800" kern="1200">
+          <a:solidFill>
+            <a:schemeClr val="tx1"/>
+          </a:solidFill>
+          <a:latin typeface="+mn-lt"/>
+          <a:ea typeface="+mn-lt"/>
+          <a:cs typeface="+mn-lt"/>
+        </a:defRPr>
+      </a:lvl2pPr>
+      <a:lvl3pPr xmlns:a="http://schemas.openxmlformats.org/drawingml/2006/main" marL="914400" algn="l" defTabSz="914400">
+        <a:buNone/>
+        <a:defRPr sz="1800" kern="1200">
+          <a:solidFill>
+            <a:schemeClr val="tx1"/>
+          </a:solidFill>
+          <a:latin typeface="+mn-lt"/>
+          <a:ea typeface="+mn-lt"/>
+          <a:cs typeface="+mn-lt"/>
+        </a:defRPr>
+      </a:lvl3pPr>
+      <a:lvl4pPr xmlns:a="http://schemas.openxmlformats.org/drawingml/2006/main" marL="1371600" algn="l" defTabSz="914400">
+        <a:buNone/>
+        <a:defRPr sz="1800" kern="1200">
+          <a:solidFill>
+            <a:schemeClr val="tx1"/>
+          </a:solidFill>
+          <a:latin typeface="+mn-lt"/>
+          <a:ea typeface="+mn-lt"/>
+          <a:cs typeface="+mn-lt"/>
+        </a:defRPr>
+      </a:lvl4pPr>
+      <a:lvl5pPr xmlns:a="http://schemas.openxmlformats.org/drawingml/2006/main" marL="1828800" algn="l" defTabSz="914400">
+        <a:buNone/>
+        <a:defRPr sz="1800" kern="1200">
+          <a:solidFill>
+            <a:schemeClr val="tx1"/>
+          </a:solidFill>
+          <a:latin typeface="+mn-lt"/>
+          <a:ea typeface="+mn-lt"/>
+          <a:cs typeface="+mn-lt"/>
+        </a:defRPr>
+      </a:lvl5pPr>
+      <a:lvl6pPr xmlns:a="http://schemas.openxmlformats.org/drawingml/2006/main" marL="2286000" algn="l" defTabSz="914400">
+        <a:buNone/>
+        <a:defRPr sz="1800" kern="1200">
+          <a:solidFill>
+            <a:schemeClr val="tx1"/>
+          </a:solidFill>
+          <a:latin typeface="+mn-lt"/>
+          <a:ea typeface="+mn-lt"/>
+          <a:cs typeface="+mn-lt"/>
+        </a:defRPr>
+      </a:lvl6pPr>
+      <a:lvl7pPr xmlns:a="http://schemas.openxmlformats.org/drawingml/2006/main" marL="2743200" algn="l" defTabSz="914400">
+        <a:buNone/>
+        <a:defRPr sz="1800" kern="1200">
+          <a:solidFill>
+            <a:schemeClr val="tx1"/>
+          </a:solidFill>
+          <a:latin typeface="+mn-lt"/>
+          <a:ea typeface="+mn-lt"/>
+          <a:cs typeface="+mn-lt"/>
+        </a:defRPr>
+      </a:lvl7pPr>
+      <a:lvl8pPr xmlns:a="http://schemas.openxmlformats.org/drawingml/2006/main" marL="3200400" algn="l" defTabSz="914400">
+        <a:buNone/>
+        <a:defRPr sz="1800" kern="1200">
+          <a:solidFill>
+            <a:schemeClr val="tx1"/>
+          </a:solidFill>
+          <a:latin typeface="+mn-lt"/>
+          <a:ea typeface="+mn-lt"/>
+          <a:cs typeface="+mn-lt"/>
+        </a:defRPr>
+      </a:lvl8pPr>
+      <a:lvl9pPr xmlns:a="http://schemas.openxmlformats.org/drawingml/2006/main" marL="3657600" algn="l" defTabSz="914400">
+        <a:buNone/>
+        <a:defRPr sz="1800" kern="1200">
+          <a:solidFill>
+            <a:schemeClr val="tx1"/>
+          </a:solidFill>
+          <a:latin typeface="+mn-lt"/>
+          <a:ea typeface="+mn-lt"/>
+          <a:cs typeface="+mn-lt"/>
+        </a:defRPr>
+      </a:lvl9pPr>
+    </p:otherStyle>
+  </p:txStyles>
+</p:sldMaster>
+</file>
+
+<file path=ppt/safety-insight/ppt/slideMasters/theme/theme2.xml><?xml version="1.0" encoding="utf-8"?>
+<a:theme xmlns:a="http://schemas.openxmlformats.org/drawingml/2006/main" name="Office Theme">
+  <a:themeElements>
+    <a:clrScheme name="Office">
+      <a:dk1>
+        <a:srgbClr val="000000"/>
+      </a:dk1>
+      <a:lt1>
+        <a:srgbClr val="FFFFFF"/>
+      </a:lt1>
+      <a:dk2>
+        <a:srgbClr val="44546A"/>
+      </a:dk2>
+      <a:lt2>
+        <a:srgbClr val="E7E6E6"/>
+      </a:lt2>
+      <a:accent1>
+        <a:srgbClr val="4472C4"/>
+      </a:accent1>
+      <a:accent2>
+        <a:srgbClr val="ED7D31"/>
+      </a:accent2>
+      <a:accent3>
+        <a:srgbClr val="A5A5A5"/>
+      </a:accent3>
+      <a:accent4>
+        <a:srgbClr val="FFC000"/>
+      </a:accent4>
+      <a:accent5>
+        <a:srgbClr val="5B9BD5"/>
+      </a:accent5>
+      <a:accent6>
+        <a:srgbClr val="70AD47"/>
+      </a:accent6>
+      <a:hlink>
+        <a:srgbClr val="0563C1"/>
+      </a:hlink>
+      <a:folHlink>
+        <a:srgbClr val="954F72"/>
+      </a:folHlink>
+    </a:clrScheme>
+    <a:fontScheme name="Office">
+      <a:majorFont>
+        <a:latin typeface="Aptos Display"/>
+        <a:ea typeface=""/>
+        <a:cs typeface=""/>
+      </a:majorFont>
+      <a:minorFont>
+        <a:latin typeface="Aptos"/>
+        <a:ea typeface=""/>
+        <a:cs typeface=""/>
+      </a:minorFont>
+    </a:fontScheme>
+    <a:fmtScheme name="Office">
+      <a:fillStyleLst>
+        <a:solidFill>
+          <a:schemeClr val="phClr"/>
+        </a:solidFill>
+        <a:gradFill>
+          <a:gsLst>
+            <a:gs pos="0">
+              <a:schemeClr val="phClr">
+                <a:tint val="67000"/>
+                <a:lumMod val="110000"/>
+              </a:schemeClr>
+            </a:gs>
+            <a:gs pos="50000">
+              <a:schemeClr val="phClr">
+                <a:tint val="73000"/>
+                <a:lumMod val="105000"/>
+              </a:schemeClr>
+            </a:gs>
+            <a:gs pos="100000">
+              <a:schemeClr val="phClr">
+                <a:tint val="81000"/>
+                <a:lumMod val="105000"/>
+              </a:schemeClr>
+            </a:gs>
+          </a:gsLst>
+          <a:lin ang="5400000" scaled="0"/>
+          <a:tileRect/>
+        </a:gradFill>
+        <a:gradFill>
+          <a:gsLst>
+            <a:gs pos="0">
+              <a:schemeClr val="phClr">
+                <a:tint val="94000"/>
+                <a:lumMod val="102000"/>
+              </a:schemeClr>
+            </a:gs>
+            <a:gs pos="50000">
+              <a:schemeClr val="phClr">
+                <a:shade val="100000"/>
+                <a:lumMod val="100000"/>
+              </a:schemeClr>
+            </a:gs>
+            <a:gs pos="100000">
+              <a:schemeClr val="phClr">
+                <a:shade val="78000"/>
+                <a:lumMod val="99000"/>
+              </a:schemeClr>
+            </a:gs>
+          </a:gsLst>
+          <a:lin ang="5400000" scaled="0"/>
+          <a:tileRect/>
+        </a:gradFill>
+      </a:fillStyleLst>
+      <a:lnStyleLst>
+        <a:ln w="6350">
+          <a:prstDash val="solid"/>
+        </a:ln>
+        <a:ln w="12700">
+          <a:prstDash val="solid"/>
+        </a:ln>
+        <a:ln w="19050">
+          <a:prstDash val="solid"/>
+        </a:ln>
+      </a:lnStyleLst>
+      <a:effectStyleLst>
+        <a:effectStyle>
+          <a:effectLst/>
+        </a:effectStyle>
+        <a:effectStyle>
+          <a:effectLst/>
+        </a:effectStyle>
+        <a:effectStyle>
+          <a:effectLst/>
+        </a:effectStyle>
+      </a:effectStyleLst>
+      <a:bgFillStyleLst>
+        <a:solidFill>
+          <a:schemeClr val="phClr"/>
+        </a:solidFill>
+        <a:solidFill>
+          <a:schemeClr val="phClr">
+            <a:tint val="95000"/>
+          </a:schemeClr>
+        </a:solidFill>
+        <a:gradFill>
+          <a:gsLst>
+            <a:gs pos="0">
+              <a:schemeClr val="phClr">
+                <a:tint val="93000"/>
+                <a:shade val="98000"/>
+                <a:lumMod val="102000"/>
+              </a:schemeClr>
+            </a:gs>
+            <a:gs pos="50000">
+              <a:schemeClr val="phClr">
+                <a:tint val="98000"/>
+                <a:shade val="90000"/>
+                <a:lumMod val="103000"/>
+              </a:schemeClr>
+            </a:gs>
+            <a:gs pos="100000">
+              <a:schemeClr val="phClr">
+                <a:shade val="63000"/>
+              </a:schemeClr>
+            </a:gs>
+          </a:gsLst>
+          <a:lin ang="5400000" scaled="0"/>
+          <a:tileRect/>
+        </a:gradFill>
+      </a:bgFillStyleLst>
+    </a:fmtScheme>
+  </a:themeElements>
+</a:theme>
+</file>
+
 <file path=ppt/slideLayouts/slideLayout1.xml><?xml version="1.0" encoding="utf-8"?>
 <p:sldLayout xmlns:a="http://schemas.openxmlformats.org/drawingml/2006/main" xmlns:r="http://schemas.openxmlformats.org/officeDocument/2006/relationships" xmlns:p="http://schemas.openxmlformats.org/presentationml/2006/main" type="blank" preserve="1">
   <p:cSld name="DEFAULT">
@@ -29234,7 +30386,7 @@
                 <a:latin typeface="Aptos"/>
                 <a:ea typeface="Aptos"/>
               </a:rPr>
-              <a:t>24</a:t>
+              <a:t>25</a:t>
             </a:r>
             <a:endParaRPr lang="en-US" sz="1000" b="0" u="none" strike="noStrike">
               <a:solidFill>
@@ -33839,11 +34991,11 @@
 </file>
 
 <file path=ppt/slides/slide26.xml><?xml version="1.0" encoding="utf-8"?>
-<p:sld xmlns:p="http://schemas.openxmlformats.org/presentationml/2006/main">
+<p:sld xmlns:a="http://schemas.openxmlformats.org/drawingml/2006/main" xmlns:ns2="http://schemas.microsoft.com/office/drawing/2014/main" xmlns:ns3="http://schemas.microsoft.com/office/powerpoint/2010/main" xmlns:p="http://schemas.openxmlformats.org/presentationml/2006/main">
   <p:cSld>
     <p:bg>
       <p:bgPr>
-        <a:solidFill xmlns:a="http://schemas.openxmlformats.org/drawingml/2006/main">
+        <a:solidFill>
           <a:srgbClr val="F7F9FC"/>
         </a:solidFill>
       </p:bgPr>
@@ -33855,34 +35007,34 @@
         <p:nvPr/>
       </p:nvGrpSpPr>
       <p:grpSpPr>
-        <a:xfrm xmlns:a="http://schemas.openxmlformats.org/drawingml/2006/main"/>
+        <a:xfrm/>
       </p:grpSpPr>
       <p:sp>
         <p:nvSpPr>
           <p:cNvPr id="13" name="Shape 0">
-            <a:extLst xmlns:a="http://schemas.openxmlformats.org/drawingml/2006/main">
+            <a:extLst>
               <a:ext uri="{FF2B5EF4-FFF2-40B4-BE49-F238E27FC236}">
-                <a16:creationId xmlns:a16="http://schemas.microsoft.com/office/drawing/2014/main" id="{0CCFAE65-8F72-4D72-8AFE-6BA4FD2F2C0C}"/>
+                <ns2:creationId id="{0CCFAE65-8F72-4D72-8AFE-6BA4FD2F2C0C}"/>
               </a:ext>
             </a:extLst>
           </p:cNvPr>
           <p:cNvSpPr>
-            <a:spLocks xmlns:a="http://schemas.openxmlformats.org/drawingml/2006/main" noGrp="1"/>
+            <a:spLocks noGrp="1"/>
           </p:cNvSpPr>
           <p:nvPr/>
         </p:nvSpPr>
         <p:spPr>
-          <a:xfrm xmlns:a="http://schemas.openxmlformats.org/drawingml/2006/main">
+          <a:xfrm>
             <a:off x="0" y="0"/>
             <a:ext cx="12191400" cy="72720"/>
           </a:xfrm>
-          <a:prstGeom xmlns:a="http://schemas.openxmlformats.org/drawingml/2006/main" prst="rect">
-            <a:avLst/>
-          </a:prstGeom>
-          <a:solidFill xmlns:a="http://schemas.openxmlformats.org/drawingml/2006/main">
+          <a:prstGeom prst="rect">
+            <a:avLst/>
+          </a:prstGeom>
+          <a:solidFill>
             <a:srgbClr val="119F9A"/>
           </a:solidFill>
-          <a:ln xmlns:a="http://schemas.openxmlformats.org/drawingml/2006/main" w="12700">
+          <a:ln w="12700">
             <a:solidFill>
               <a:srgbClr val="119F9A"/>
             </a:solidFill>
@@ -33890,17 +35042,17 @@
           </a:ln>
         </p:spPr>
         <p:style>
-          <a:lnRef xmlns:a="http://schemas.openxmlformats.org/drawingml/2006/main" idx="0"/>
-          <a:fillRef xmlns:a="http://schemas.openxmlformats.org/drawingml/2006/main" idx="0"/>
-          <a:effectRef xmlns:a="http://schemas.openxmlformats.org/drawingml/2006/main" idx="0"/>
-          <a:fontRef xmlns:a="http://schemas.openxmlformats.org/drawingml/2006/main" idx="minor"/>
-        </p:style>
-        <p:txBody>
-          <a:bodyPr xmlns:a="http://schemas.openxmlformats.org/drawingml/2006/main" lIns="90000" tIns="28080" rIns="90000" bIns="28080" anchor="t">
+          <a:lnRef idx="0"/>
+          <a:fillRef idx="0"/>
+          <a:effectRef idx="0"/>
+          <a:fontRef idx="minor"/>
+        </p:style>
+        <p:txBody>
+          <a:bodyPr lIns="90000" tIns="28080" rIns="90000" bIns="28080" anchor="t">
             <a:noAutofit/>
           </a:bodyPr>
-          <a:lstStyle xmlns:a="http://schemas.openxmlformats.org/drawingml/2006/main"/>
-          <a:p xmlns:a="http://schemas.openxmlformats.org/drawingml/2006/main">
+          <a:lstStyle/>
+          <a:p>
             <a:endParaRPr sz="1800" b="0" u="none" strike="noStrike">
               <a:solidFill>
                 <a:srgbClr val="FFFFFF"/>
@@ -33915,42 +35067,42 @@
       <p:sp>
         <p:nvSpPr>
           <p:cNvPr id="2" name="Text 1">
-            <a:extLst xmlns:a="http://schemas.openxmlformats.org/drawingml/2006/main">
+            <a:extLst>
               <a:ext uri="{FF2B5EF4-FFF2-40B4-BE49-F238E27FC236}">
-                <a16:creationId xmlns:a16="http://schemas.microsoft.com/office/drawing/2014/main" id="{2C4FD076-E356-4DE8-8195-3ECF99E05922}"/>
+                <ns2:creationId id="{2C4FD076-E356-4DE8-8195-3ECF99E05922}"/>
               </a:ext>
             </a:extLst>
           </p:cNvPr>
           <p:cNvSpPr>
-            <a:spLocks xmlns:a="http://schemas.openxmlformats.org/drawingml/2006/main" noGrp="1"/>
+            <a:spLocks noGrp="1"/>
           </p:cNvSpPr>
           <p:nvPr/>
         </p:nvSpPr>
         <p:spPr>
-          <a:xfrm xmlns:a="http://schemas.openxmlformats.org/drawingml/2006/main">
+          <a:xfrm>
             <a:off x="567000" y="274320"/>
             <a:ext cx="10058040" cy="228240"/>
           </a:xfrm>
-          <a:prstGeom xmlns:a="http://schemas.openxmlformats.org/drawingml/2006/main" prst="rect">
-            <a:avLst/>
-          </a:prstGeom>
-          <a:noFill xmlns:a="http://schemas.openxmlformats.org/drawingml/2006/main"/>
-          <a:ln xmlns:a="http://schemas.openxmlformats.org/drawingml/2006/main" w="0">
+          <a:prstGeom prst="rect">
+            <a:avLst/>
+          </a:prstGeom>
+          <a:noFill/>
+          <a:ln w="0">
             <a:noFill/>
           </a:ln>
         </p:spPr>
         <p:style>
-          <a:lnRef xmlns:a="http://schemas.openxmlformats.org/drawingml/2006/main" idx="0"/>
-          <a:fillRef xmlns:a="http://schemas.openxmlformats.org/drawingml/2006/main" idx="0"/>
-          <a:effectRef xmlns:a="http://schemas.openxmlformats.org/drawingml/2006/main" idx="0"/>
-          <a:fontRef xmlns:a="http://schemas.openxmlformats.org/drawingml/2006/main" idx="minor"/>
-        </p:style>
-        <p:txBody>
-          <a:bodyPr xmlns:a="http://schemas.openxmlformats.org/drawingml/2006/main" lIns="0" tIns="0" rIns="0" bIns="0" anchor="ctr">
+          <a:lnRef idx="0"/>
+          <a:fillRef idx="0"/>
+          <a:effectRef idx="0"/>
+          <a:fontRef idx="minor"/>
+        </p:style>
+        <p:txBody>
+          <a:bodyPr lIns="0" tIns="0" rIns="0" bIns="0" anchor="ctr">
             <a:normAutofit fontScale="100000"/>
           </a:bodyPr>
-          <a:lstStyle xmlns:a="http://schemas.openxmlformats.org/drawingml/2006/main"/>
-          <a:p xmlns:a="http://schemas.openxmlformats.org/drawingml/2006/main">
+          <a:lstStyle/>
+          <a:p>
             <a:pPr defTabSz="914400">
               <a:lnSpc>
                 <a:spcPct val="100000"/>
@@ -33985,42 +35137,42 @@
       <p:sp>
         <p:nvSpPr>
           <p:cNvPr id="3" name="Text 2">
-            <a:extLst xmlns:a="http://schemas.openxmlformats.org/drawingml/2006/main">
+            <a:extLst>
               <a:ext uri="{FF2B5EF4-FFF2-40B4-BE49-F238E27FC236}">
-                <a16:creationId xmlns:a16="http://schemas.microsoft.com/office/drawing/2014/main" id="{315468C8-12EC-4557-98B5-FDC3DBF2C4F1}"/>
+                <ns2:creationId id="{315468C8-12EC-4557-98B5-FDC3DBF2C4F1}"/>
               </a:ext>
             </a:extLst>
           </p:cNvPr>
           <p:cNvSpPr>
-            <a:spLocks xmlns:a="http://schemas.openxmlformats.org/drawingml/2006/main" noGrp="1"/>
+            <a:spLocks noGrp="1"/>
           </p:cNvSpPr>
           <p:nvPr/>
         </p:nvSpPr>
         <p:spPr>
-          <a:xfrm xmlns:a="http://schemas.openxmlformats.org/drawingml/2006/main">
+          <a:xfrm>
             <a:off x="567000" y="621720"/>
             <a:ext cx="11018160" cy="520920"/>
           </a:xfrm>
-          <a:prstGeom xmlns:a="http://schemas.openxmlformats.org/drawingml/2006/main" prst="rect">
-            <a:avLst/>
-          </a:prstGeom>
-          <a:noFill xmlns:a="http://schemas.openxmlformats.org/drawingml/2006/main"/>
-          <a:ln xmlns:a="http://schemas.openxmlformats.org/drawingml/2006/main" w="0">
+          <a:prstGeom prst="rect">
+            <a:avLst/>
+          </a:prstGeom>
+          <a:noFill/>
+          <a:ln w="0">
             <a:noFill/>
           </a:ln>
         </p:spPr>
         <p:style>
-          <a:lnRef xmlns:a="http://schemas.openxmlformats.org/drawingml/2006/main" idx="0"/>
-          <a:fillRef xmlns:a="http://schemas.openxmlformats.org/drawingml/2006/main" idx="0"/>
-          <a:effectRef xmlns:a="http://schemas.openxmlformats.org/drawingml/2006/main" idx="0"/>
-          <a:fontRef xmlns:a="http://schemas.openxmlformats.org/drawingml/2006/main" idx="minor"/>
-        </p:style>
-        <p:txBody>
-          <a:bodyPr xmlns:a="http://schemas.openxmlformats.org/drawingml/2006/main" lIns="0" tIns="0" rIns="0" bIns="0" anchor="ctr">
+          <a:lnRef idx="0"/>
+          <a:fillRef idx="0"/>
+          <a:effectRef idx="0"/>
+          <a:fontRef idx="minor"/>
+        </p:style>
+        <p:txBody>
+          <a:bodyPr lIns="0" tIns="0" rIns="0" bIns="0" anchor="ctr">
             <a:normAutofit fontScale="100000"/>
           </a:bodyPr>
-          <a:lstStyle xmlns:a="http://schemas.openxmlformats.org/drawingml/2006/main"/>
-          <a:p xmlns:a="http://schemas.openxmlformats.org/drawingml/2006/main">
+          <a:lstStyle/>
+          <a:p>
             <a:pPr defTabSz="914400">
               <a:lnSpc>
                 <a:spcPct val="100000"/>
@@ -34055,26 +35207,26 @@
       <p:sp>
         <p:nvSpPr>
           <p:cNvPr id="4" name="Shape 3">
-            <a:extLst xmlns:a="http://schemas.openxmlformats.org/drawingml/2006/main">
+            <a:extLst>
               <a:ext uri="{FF2B5EF4-FFF2-40B4-BE49-F238E27FC236}">
-                <a16:creationId xmlns:a16="http://schemas.microsoft.com/office/drawing/2014/main" id="{F13AF7BF-A49E-4E4F-8D2D-FB40ADA32A60}"/>
+                <ns2:creationId id="{F13AF7BF-A49E-4E4F-8D2D-FB40ADA32A60}"/>
               </a:ext>
             </a:extLst>
           </p:cNvPr>
           <p:cNvSpPr>
-            <a:spLocks xmlns:a="http://schemas.openxmlformats.org/drawingml/2006/main" noGrp="1"/>
+            <a:spLocks noGrp="1"/>
           </p:cNvSpPr>
           <p:nvPr/>
         </p:nvSpPr>
         <p:spPr>
-          <a:xfrm xmlns:a="http://schemas.openxmlformats.org/drawingml/2006/main">
+          <a:xfrm>
             <a:off x="566640" y="1280160"/>
             <a:ext cx="11064240" cy="360"/>
           </a:xfrm>
-          <a:prstGeom xmlns:a="http://schemas.openxmlformats.org/drawingml/2006/main" prst="line">
-            <a:avLst/>
-          </a:prstGeom>
-          <a:ln xmlns:a="http://schemas.openxmlformats.org/drawingml/2006/main" w="12700">
+          <a:prstGeom prst="line">
+            <a:avLst/>
+          </a:prstGeom>
+          <a:ln w="12700">
             <a:solidFill>
               <a:srgbClr val="DCE5ED"/>
             </a:solidFill>
@@ -34082,17 +35234,17 @@
           </a:ln>
         </p:spPr>
         <p:style>
-          <a:lnRef xmlns:a="http://schemas.openxmlformats.org/drawingml/2006/main" idx="0"/>
-          <a:fillRef xmlns:a="http://schemas.openxmlformats.org/drawingml/2006/main" idx="0"/>
-          <a:effectRef xmlns:a="http://schemas.openxmlformats.org/drawingml/2006/main" idx="0"/>
-          <a:fontRef xmlns:a="http://schemas.openxmlformats.org/drawingml/2006/main" idx="minor"/>
-        </p:style>
-        <p:txBody>
-          <a:bodyPr xmlns:a="http://schemas.openxmlformats.org/drawingml/2006/main" lIns="90000" tIns="-44640" rIns="90000" bIns="-44640" anchor="t">
+          <a:lnRef idx="0"/>
+          <a:fillRef idx="0"/>
+          <a:effectRef idx="0"/>
+          <a:fontRef idx="minor"/>
+        </p:style>
+        <p:txBody>
+          <a:bodyPr lIns="90000" tIns="-44640" rIns="90000" bIns="-44640" anchor="t">
             <a:noAutofit/>
           </a:bodyPr>
-          <a:lstStyle xmlns:a="http://schemas.openxmlformats.org/drawingml/2006/main"/>
-          <a:p xmlns:a="http://schemas.openxmlformats.org/drawingml/2006/main">
+          <a:lstStyle/>
+          <a:p>
             <a:endParaRPr sz="1800" b="0" u="none" strike="noStrike">
               <a:solidFill>
                 <a:srgbClr val="000000"/>
@@ -34107,26 +35259,26 @@
       <p:sp>
         <p:nvSpPr>
           <p:cNvPr id="5" name="Shape 4">
-            <a:extLst xmlns:a="http://schemas.openxmlformats.org/drawingml/2006/main">
+            <a:extLst>
               <a:ext uri="{FF2B5EF4-FFF2-40B4-BE49-F238E27FC236}">
-                <a16:creationId xmlns:a16="http://schemas.microsoft.com/office/drawing/2014/main" id="{189D63D6-788F-49D0-8C5C-EDD51865DA3F}"/>
+                <ns2:creationId id="{189D63D6-788F-49D0-8C5C-EDD51865DA3F}"/>
               </a:ext>
             </a:extLst>
           </p:cNvPr>
           <p:cNvSpPr>
-            <a:spLocks xmlns:a="http://schemas.openxmlformats.org/drawingml/2006/main" noGrp="1"/>
+            <a:spLocks noGrp="1"/>
           </p:cNvSpPr>
           <p:nvPr/>
         </p:nvSpPr>
         <p:spPr>
-          <a:xfrm xmlns:a="http://schemas.openxmlformats.org/drawingml/2006/main">
+          <a:xfrm>
             <a:off x="566640" y="6519600"/>
             <a:ext cx="11064240" cy="360"/>
           </a:xfrm>
-          <a:prstGeom xmlns:a="http://schemas.openxmlformats.org/drawingml/2006/main" prst="line">
-            <a:avLst/>
-          </a:prstGeom>
-          <a:ln xmlns:a="http://schemas.openxmlformats.org/drawingml/2006/main" w="12700">
+          <a:prstGeom prst="line">
+            <a:avLst/>
+          </a:prstGeom>
+          <a:ln w="12700">
             <a:solidFill>
               <a:srgbClr val="DCE5ED"/>
             </a:solidFill>
@@ -34134,17 +35286,17 @@
           </a:ln>
         </p:spPr>
         <p:style>
-          <a:lnRef xmlns:a="http://schemas.openxmlformats.org/drawingml/2006/main" idx="0"/>
-          <a:fillRef xmlns:a="http://schemas.openxmlformats.org/drawingml/2006/main" idx="0"/>
-          <a:effectRef xmlns:a="http://schemas.openxmlformats.org/drawingml/2006/main" idx="0"/>
-          <a:fontRef xmlns:a="http://schemas.openxmlformats.org/drawingml/2006/main" idx="minor"/>
-        </p:style>
-        <p:txBody>
-          <a:bodyPr xmlns:a="http://schemas.openxmlformats.org/drawingml/2006/main" lIns="90000" tIns="-44640" rIns="90000" bIns="-44640" anchor="t">
+          <a:lnRef idx="0"/>
+          <a:fillRef idx="0"/>
+          <a:effectRef idx="0"/>
+          <a:fontRef idx="minor"/>
+        </p:style>
+        <p:txBody>
+          <a:bodyPr lIns="90000" tIns="-44640" rIns="90000" bIns="-44640" anchor="t">
             <a:noAutofit/>
           </a:bodyPr>
-          <a:lstStyle xmlns:a="http://schemas.openxmlformats.org/drawingml/2006/main"/>
-          <a:p xmlns:a="http://schemas.openxmlformats.org/drawingml/2006/main">
+          <a:lstStyle/>
+          <a:p>
             <a:endParaRPr sz="1800" b="0" u="none" strike="noStrike">
               <a:solidFill>
                 <a:srgbClr val="000000"/>
@@ -34159,42 +35311,42 @@
       <p:sp>
         <p:nvSpPr>
           <p:cNvPr id="6" name="Text 5">
-            <a:extLst xmlns:a="http://schemas.openxmlformats.org/drawingml/2006/main">
+            <a:extLst>
               <a:ext uri="{FF2B5EF4-FFF2-40B4-BE49-F238E27FC236}">
-                <a16:creationId xmlns:a16="http://schemas.microsoft.com/office/drawing/2014/main" id="{3DE2DF10-865B-4173-A370-EA1BDA3B3EB5}"/>
+                <ns2:creationId id="{3DE2DF10-865B-4173-A370-EA1BDA3B3EB5}"/>
               </a:ext>
             </a:extLst>
           </p:cNvPr>
           <p:cNvSpPr>
-            <a:spLocks xmlns:a="http://schemas.openxmlformats.org/drawingml/2006/main" noGrp="1"/>
+            <a:spLocks noGrp="1"/>
           </p:cNvSpPr>
           <p:nvPr/>
         </p:nvSpPr>
         <p:spPr>
-          <a:xfrm xmlns:a="http://schemas.openxmlformats.org/drawingml/2006/main">
+          <a:xfrm>
             <a:off x="594360" y="6574680"/>
             <a:ext cx="10423800" cy="164160"/>
           </a:xfrm>
-          <a:prstGeom xmlns:a="http://schemas.openxmlformats.org/drawingml/2006/main" prst="rect">
-            <a:avLst/>
-          </a:prstGeom>
-          <a:noFill xmlns:a="http://schemas.openxmlformats.org/drawingml/2006/main"/>
-          <a:ln xmlns:a="http://schemas.openxmlformats.org/drawingml/2006/main" w="0">
+          <a:prstGeom prst="rect">
+            <a:avLst/>
+          </a:prstGeom>
+          <a:noFill/>
+          <a:ln w="0">
             <a:noFill/>
           </a:ln>
         </p:spPr>
         <p:style>
-          <a:lnRef xmlns:a="http://schemas.openxmlformats.org/drawingml/2006/main" idx="0"/>
-          <a:fillRef xmlns:a="http://schemas.openxmlformats.org/drawingml/2006/main" idx="0"/>
-          <a:effectRef xmlns:a="http://schemas.openxmlformats.org/drawingml/2006/main" idx="0"/>
-          <a:fontRef xmlns:a="http://schemas.openxmlformats.org/drawingml/2006/main" idx="minor"/>
-        </p:style>
-        <p:txBody>
-          <a:bodyPr xmlns:a="http://schemas.openxmlformats.org/drawingml/2006/main" lIns="0" tIns="0" rIns="0" bIns="0" anchor="ctr">
+          <a:lnRef idx="0"/>
+          <a:fillRef idx="0"/>
+          <a:effectRef idx="0"/>
+          <a:fontRef idx="minor"/>
+        </p:style>
+        <p:txBody>
+          <a:bodyPr lIns="0" tIns="0" rIns="0" bIns="0" anchor="ctr">
             <a:normAutofit fontScale="100000"/>
           </a:bodyPr>
-          <a:lstStyle xmlns:a="http://schemas.openxmlformats.org/drawingml/2006/main"/>
-          <a:p xmlns:a="http://schemas.openxmlformats.org/drawingml/2006/main">
+          <a:lstStyle/>
+          <a:p>
             <a:pPr defTabSz="914400">
               <a:lnSpc>
                 <a:spcPct val="100000"/>
@@ -34229,42 +35381,42 @@
       <p:sp>
         <p:nvSpPr>
           <p:cNvPr id="7" name="Text 6">
-            <a:extLst xmlns:a="http://schemas.openxmlformats.org/drawingml/2006/main">
+            <a:extLst>
               <a:ext uri="{FF2B5EF4-FFF2-40B4-BE49-F238E27FC236}">
-                <a16:creationId xmlns:a16="http://schemas.microsoft.com/office/drawing/2014/main" id="{A05CF2ED-F969-4FF6-9ED9-5A816DB56D30}"/>
+                <ns2:creationId id="{A05CF2ED-F969-4FF6-9ED9-5A816DB56D30}"/>
               </a:ext>
             </a:extLst>
           </p:cNvPr>
           <p:cNvSpPr>
-            <a:spLocks xmlns:a="http://schemas.openxmlformats.org/drawingml/2006/main" noGrp="1"/>
+            <a:spLocks noGrp="1"/>
           </p:cNvSpPr>
           <p:nvPr/>
         </p:nvSpPr>
         <p:spPr>
-          <a:xfrm xmlns:a="http://schemas.openxmlformats.org/drawingml/2006/main">
+          <a:xfrm>
             <a:off x="11155680" y="6537960"/>
             <a:ext cx="438480" cy="228240"/>
           </a:xfrm>
-          <a:prstGeom xmlns:a="http://schemas.openxmlformats.org/drawingml/2006/main" prst="rect">
-            <a:avLst/>
-          </a:prstGeom>
-          <a:noFill xmlns:a="http://schemas.openxmlformats.org/drawingml/2006/main"/>
-          <a:ln xmlns:a="http://schemas.openxmlformats.org/drawingml/2006/main" w="0">
+          <a:prstGeom prst="rect">
+            <a:avLst/>
+          </a:prstGeom>
+          <a:noFill/>
+          <a:ln w="0">
             <a:noFill/>
           </a:ln>
         </p:spPr>
         <p:style>
-          <a:lnRef xmlns:a="http://schemas.openxmlformats.org/drawingml/2006/main" idx="0"/>
-          <a:fillRef xmlns:a="http://schemas.openxmlformats.org/drawingml/2006/main" idx="0"/>
-          <a:effectRef xmlns:a="http://schemas.openxmlformats.org/drawingml/2006/main" idx="0"/>
-          <a:fontRef xmlns:a="http://schemas.openxmlformats.org/drawingml/2006/main" idx="minor"/>
-        </p:style>
-        <p:txBody>
-          <a:bodyPr xmlns:a="http://schemas.openxmlformats.org/drawingml/2006/main" lIns="0" tIns="0" rIns="0" bIns="0" anchor="ctr">
+          <a:lnRef idx="0"/>
+          <a:fillRef idx="0"/>
+          <a:effectRef idx="0"/>
+          <a:fontRef idx="minor"/>
+        </p:style>
+        <p:txBody>
+          <a:bodyPr lIns="0" tIns="0" rIns="0" bIns="0" anchor="ctr">
             <a:normAutofit fontScale="100000"/>
           </a:bodyPr>
-          <a:lstStyle xmlns:a="http://schemas.openxmlformats.org/drawingml/2006/main"/>
-          <a:p xmlns:a="http://schemas.openxmlformats.org/drawingml/2006/main">
+          <a:lstStyle/>
+          <a:p>
             <a:pPr algn="r" defTabSz="914400">
               <a:lnSpc>
                 <a:spcPct val="100000"/>
@@ -34283,7 +35435,7 @@
                 <a:ea typeface="Aptos"/>
                 <a:cs typeface="Aptos"/>
               </a:rPr>
-              <a:t>25</a:t>
+              <a:t>26</a:t>
             </a:r>
             <a:endParaRPr sz="1000" b="0" u="none" strike="noStrike">
               <a:solidFill>
@@ -34299,33 +35451,33 @@
       <p:sp>
         <p:nvSpPr>
           <p:cNvPr id="8" name="">
-            <a:extLst xmlns:a="http://schemas.openxmlformats.org/drawingml/2006/main">
+            <a:extLst>
               <a:ext uri="{FF2B5EF4-FFF2-40B4-BE49-F238E27FC236}">
-                <a16:creationId xmlns:a16="http://schemas.microsoft.com/office/drawing/2014/main" id="{5EA0E3D3-A84B-4377-9342-160F43CB16FC}"/>
+                <ns2:creationId id="{5EA0E3D3-A84B-4377-9342-160F43CB16FC}"/>
               </a:ext>
             </a:extLst>
           </p:cNvPr>
           <p:cNvSpPr>
-            <a:spLocks xmlns:a="http://schemas.openxmlformats.org/drawingml/2006/main" noGrp="1"/>
+            <a:spLocks noGrp="1"/>
           </p:cNvSpPr>
           <p:nvPr/>
         </p:nvSpPr>
         <p:spPr>
-          <a:xfrm xmlns:a="http://schemas.openxmlformats.org/drawingml/2006/main">
+          <a:xfrm>
             <a:off x="590550" y="1609725"/>
             <a:ext cx="10858500" cy="400050"/>
           </a:xfrm>
-          <a:prstGeom xmlns:a="http://schemas.openxmlformats.org/drawingml/2006/main" prst="rect">
-            <a:avLst/>
-          </a:prstGeom>
-          <a:noFill xmlns:a="http://schemas.openxmlformats.org/drawingml/2006/main"/>
-          <a:ln xmlns:a="http://schemas.openxmlformats.org/drawingml/2006/main" w="0">
+          <a:prstGeom prst="rect">
+            <a:avLst/>
+          </a:prstGeom>
+          <a:noFill/>
+          <a:ln w="0">
             <a:noFill/>
           </a:ln>
         </p:spPr>
         <p:txBody>
-          <a:bodyPr xmlns:a="http://schemas.openxmlformats.org/drawingml/2006/main"/>
-          <a:lstStyle xmlns:a="http://schemas.openxmlformats.org/drawingml/2006/main">
+          <a:bodyPr/>
+          <a:lstStyle>
             <a:defPPr>
               <a:defRPr sz="2025" b="1">
                 <a:solidFill>
@@ -34397,7 +35549,7 @@
               </a:defRPr>
             </a:lvl9pPr>
           </a:lstStyle>
-          <a:p xmlns:a="http://schemas.openxmlformats.org/drawingml/2006/main">
+          <a:p>
             <a:pPr>
               <a:defRPr sz="2025" b="1">
                 <a:solidFill>
@@ -34419,33 +35571,33 @@
       <p:sp>
         <p:nvSpPr>
           <p:cNvPr id="9" name="">
-            <a:extLst xmlns:a="http://schemas.openxmlformats.org/drawingml/2006/main">
+            <a:extLst>
               <a:ext uri="{FF2B5EF4-FFF2-40B4-BE49-F238E27FC236}">
-                <a16:creationId xmlns:a16="http://schemas.microsoft.com/office/drawing/2014/main" id="{C40F1311-1683-4DDB-893B-BC59197BEA19}"/>
+                <ns2:creationId id="{C40F1311-1683-4DDB-893B-BC59197BEA19}"/>
               </a:ext>
             </a:extLst>
           </p:cNvPr>
           <p:cNvSpPr>
-            <a:spLocks xmlns:a="http://schemas.openxmlformats.org/drawingml/2006/main" noGrp="1"/>
+            <a:spLocks noGrp="1"/>
           </p:cNvSpPr>
           <p:nvPr/>
         </p:nvSpPr>
         <p:spPr>
-          <a:xfrm xmlns:a="http://schemas.openxmlformats.org/drawingml/2006/main">
+          <a:xfrm>
             <a:off x="590550" y="2095500"/>
             <a:ext cx="10858500" cy="361950"/>
           </a:xfrm>
-          <a:prstGeom xmlns:a="http://schemas.openxmlformats.org/drawingml/2006/main" prst="rect">
-            <a:avLst/>
-          </a:prstGeom>
-          <a:noFill xmlns:a="http://schemas.openxmlformats.org/drawingml/2006/main"/>
-          <a:ln xmlns:a="http://schemas.openxmlformats.org/drawingml/2006/main" w="0">
+          <a:prstGeom prst="rect">
+            <a:avLst/>
+          </a:prstGeom>
+          <a:noFill/>
+          <a:ln w="0">
             <a:noFill/>
           </a:ln>
         </p:spPr>
         <p:txBody>
-          <a:bodyPr xmlns:a="http://schemas.openxmlformats.org/drawingml/2006/main"/>
-          <a:lstStyle xmlns:a="http://schemas.openxmlformats.org/drawingml/2006/main">
+          <a:bodyPr/>
+          <a:lstStyle>
             <a:defPPr>
               <a:defRPr sz="1800" b="0">
                 <a:solidFill>
@@ -34517,7 +35669,7 @@
               </a:defRPr>
             </a:lvl9pPr>
           </a:lstStyle>
-          <a:p xmlns:a="http://schemas.openxmlformats.org/drawingml/2006/main">
+          <a:p>
             <a:pPr>
               <a:defRPr sz="1800" b="0">
                 <a:solidFill>
@@ -34539,9 +35691,9 @@
       <p:graphicFrame>
         <p:nvGraphicFramePr>
           <p:cNvPr id="10" name="">
-            <a:extLst xmlns:a="http://schemas.openxmlformats.org/drawingml/2006/main">
+            <a:extLst>
               <a:ext uri="{FF2B5EF4-FFF2-40B4-BE49-F238E27FC236}">
-                <a16:creationId xmlns:a16="http://schemas.microsoft.com/office/drawing/2014/main" id="{64F21179-4D3E-4210-B875-AFDEDE14F215}"/>
+                <ns2:creationId id="{64F21179-4D3E-4210-B875-AFDEDE14F215}"/>
               </a:ext>
             </a:extLst>
           </p:cNvPr>
@@ -34549,10 +35701,10 @@
           <p:nvPr/>
         </p:nvGraphicFramePr>
         <p:xfrm>
-          <a:off xmlns:a="http://schemas.openxmlformats.org/drawingml/2006/main" x="590550" y="2724150"/>
-          <a:ext xmlns:a="http://schemas.openxmlformats.org/drawingml/2006/main" cx="11010900" cy="2343150"/>
+          <a:off x="590550" y="2724150"/>
+          <a:ext cx="11010900" cy="2343150"/>
         </p:xfrm>
-        <a:graphic xmlns:a="http://schemas.openxmlformats.org/drawingml/2006/main">
+        <a:graphic>
           <a:graphicData uri="http://schemas.openxmlformats.org/drawingml/2006/table">
             <a:tbl>
               <a:tblPr/>
@@ -35292,33 +36444,33 @@
       <p:sp>
         <p:nvSpPr>
           <p:cNvPr id="11" name="">
-            <a:extLst xmlns:a="http://schemas.openxmlformats.org/drawingml/2006/main">
+            <a:extLst>
               <a:ext uri="{FF2B5EF4-FFF2-40B4-BE49-F238E27FC236}">
-                <a16:creationId xmlns:a16="http://schemas.microsoft.com/office/drawing/2014/main" id="{10A88CAC-66D5-4DE9-90BB-B25FE840EDD4}"/>
+                <ns2:creationId id="{10A88CAC-66D5-4DE9-90BB-B25FE840EDD4}"/>
               </a:ext>
             </a:extLst>
           </p:cNvPr>
           <p:cNvSpPr>
-            <a:spLocks xmlns:a="http://schemas.openxmlformats.org/drawingml/2006/main" noGrp="1"/>
+            <a:spLocks noGrp="1"/>
           </p:cNvSpPr>
           <p:nvPr/>
         </p:nvSpPr>
         <p:spPr>
-          <a:xfrm xmlns:a="http://schemas.openxmlformats.org/drawingml/2006/main">
+          <a:xfrm>
             <a:off x="590550" y="5305425"/>
             <a:ext cx="11010900" cy="438150"/>
           </a:xfrm>
-          <a:prstGeom xmlns:a="http://schemas.openxmlformats.org/drawingml/2006/main" prst="rect">
-            <a:avLst/>
-          </a:prstGeom>
-          <a:noFill xmlns:a="http://schemas.openxmlformats.org/drawingml/2006/main"/>
-          <a:ln xmlns:a="http://schemas.openxmlformats.org/drawingml/2006/main" w="0">
+          <a:prstGeom prst="rect">
+            <a:avLst/>
+          </a:prstGeom>
+          <a:noFill/>
+          <a:ln w="0">
             <a:noFill/>
           </a:ln>
         </p:spPr>
         <p:txBody>
-          <a:bodyPr xmlns:a="http://schemas.openxmlformats.org/drawingml/2006/main"/>
-          <a:lstStyle xmlns:a="http://schemas.openxmlformats.org/drawingml/2006/main">
+          <a:bodyPr/>
+          <a:lstStyle>
             <a:defPPr>
               <a:defRPr sz="1725" b="0">
                 <a:solidFill>
@@ -35390,7 +36542,7 @@
               </a:defRPr>
             </a:lvl9pPr>
           </a:lstStyle>
-          <a:p xmlns:a="http://schemas.openxmlformats.org/drawingml/2006/main">
+          <a:p>
             <a:pPr>
               <a:defRPr sz="1725" b="0">
                 <a:solidFill>
@@ -35412,33 +36564,33 @@
       <p:sp>
         <p:nvSpPr>
           <p:cNvPr id="12" name="">
-            <a:extLst xmlns:a="http://schemas.openxmlformats.org/drawingml/2006/main">
+            <a:extLst>
               <a:ext uri="{FF2B5EF4-FFF2-40B4-BE49-F238E27FC236}">
-                <a16:creationId xmlns:a16="http://schemas.microsoft.com/office/drawing/2014/main" id="{AC8C625A-66D2-42FB-81ED-1BF6A40AE46A}"/>
+                <ns2:creationId id="{AC8C625A-66D2-42FB-81ED-1BF6A40AE46A}"/>
               </a:ext>
             </a:extLst>
           </p:cNvPr>
           <p:cNvSpPr>
-            <a:spLocks xmlns:a="http://schemas.openxmlformats.org/drawingml/2006/main" noGrp="1"/>
+            <a:spLocks noGrp="1"/>
           </p:cNvSpPr>
           <p:nvPr/>
         </p:nvSpPr>
         <p:spPr>
-          <a:xfrm xmlns:a="http://schemas.openxmlformats.org/drawingml/2006/main">
+          <a:xfrm>
             <a:off x="590550" y="5819775"/>
             <a:ext cx="11010900" cy="400050"/>
           </a:xfrm>
-          <a:prstGeom xmlns:a="http://schemas.openxmlformats.org/drawingml/2006/main" prst="rect">
-            <a:avLst/>
-          </a:prstGeom>
-          <a:noFill xmlns:a="http://schemas.openxmlformats.org/drawingml/2006/main"/>
-          <a:ln xmlns:a="http://schemas.openxmlformats.org/drawingml/2006/main" w="0">
+          <a:prstGeom prst="rect">
+            <a:avLst/>
+          </a:prstGeom>
+          <a:noFill/>
+          <a:ln w="0">
             <a:noFill/>
           </a:ln>
         </p:spPr>
         <p:txBody>
-          <a:bodyPr xmlns:a="http://schemas.openxmlformats.org/drawingml/2006/main"/>
-          <a:lstStyle xmlns:a="http://schemas.openxmlformats.org/drawingml/2006/main">
+          <a:bodyPr/>
+          <a:lstStyle>
             <a:defPPr>
               <a:defRPr sz="1875" b="1">
                 <a:solidFill>
@@ -35510,7 +36662,7 @@
               </a:defRPr>
             </a:lvl9pPr>
           </a:lstStyle>
-          <a:p xmlns:a="http://schemas.openxmlformats.org/drawingml/2006/main">
+          <a:p>
             <a:pPr>
               <a:defRPr sz="1875" b="1">
                 <a:solidFill>
@@ -35532,7 +36684,1848 @@
     </p:spTree>
     <p:extLst>
       <p:ext uri="{BB962C8B-B14F-4D97-AF65-F5344CB8AC3E}">
-        <p14:creationId xmlns:p14="http://schemas.microsoft.com/office/powerpoint/2010/main" val="1374121144"/>
+        <ns3:creationId val="1374121144"/>
+      </p:ext>
+    </p:extLst>
+  </p:cSld>
+</p:sld>
+</file>
+
+<file path=ppt/slides/slide27.xml><?xml version="1.0" encoding="utf-8"?>
+<p:sld xmlns:a="http://schemas.openxmlformats.org/drawingml/2006/main" xmlns:ns2="http://schemas.microsoft.com/office/drawing/2014/main" xmlns:ns4="http://schemas.microsoft.com/office/powerpoint/2010/main" xmlns:p="http://schemas.openxmlformats.org/presentationml/2006/main" xmlns:r="http://schemas.openxmlformats.org/officeDocument/2006/relationships">
+  <p:cSld>
+    <p:bg>
+      <p:bgPr>
+        <a:solidFill>
+          <a:srgbClr val="F7F9FC"/>
+        </a:solidFill>
+      </p:bgPr>
+    </p:bg>
+    <p:spTree>
+      <p:nvGrpSpPr>
+        <p:cNvPr id="1" name=""/>
+        <p:cNvGrpSpPr/>
+        <p:nvPr/>
+      </p:nvGrpSpPr>
+      <p:grpSpPr>
+        <a:xfrm/>
+      </p:grpSpPr>
+      <p:sp>
+        <p:nvSpPr>
+          <p:cNvPr id="19" name="Shape 0">
+            <a:extLst>
+              <a:ext uri="{FF2B5EF4-FFF2-40B4-BE49-F238E27FC236}">
+                <ns2:creationId id="{0CCFAE65-8F72-4D72-8AFE-6BA4FD2F2C0C}"/>
+              </a:ext>
+            </a:extLst>
+          </p:cNvPr>
+          <p:cNvSpPr>
+            <a:spLocks noGrp="1"/>
+          </p:cNvSpPr>
+          <p:nvPr/>
+        </p:nvSpPr>
+        <p:spPr>
+          <a:xfrm>
+            <a:off x="0" y="0"/>
+            <a:ext cx="12191400" cy="72720"/>
+          </a:xfrm>
+          <a:prstGeom prst="rect">
+            <a:avLst/>
+          </a:prstGeom>
+          <a:solidFill>
+            <a:srgbClr val="119F9A"/>
+          </a:solidFill>
+          <a:ln w="12700">
+            <a:solidFill>
+              <a:srgbClr val="119F9A"/>
+            </a:solidFill>
+            <a:round/>
+          </a:ln>
+        </p:spPr>
+        <p:style>
+          <a:lnRef idx="0"/>
+          <a:fillRef idx="0"/>
+          <a:effectRef idx="0"/>
+          <a:fontRef idx="minor"/>
+        </p:style>
+        <p:txBody>
+          <a:bodyPr lIns="90000" tIns="28080" rIns="90000" bIns="28080" anchor="t">
+            <a:noAutofit/>
+          </a:bodyPr>
+          <a:lstStyle/>
+          <a:p>
+            <a:endParaRPr sz="1800" b="0" u="none" strike="noStrike">
+              <a:solidFill>
+                <a:srgbClr val="FFFFFF"/>
+              </a:solidFill>
+              <a:latin typeface="Arial"/>
+              <a:ea typeface="Arial"/>
+              <a:cs typeface="Arial"/>
+            </a:endParaRPr>
+          </a:p>
+        </p:txBody>
+      </p:sp>
+      <p:sp>
+        <p:nvSpPr>
+          <p:cNvPr id="2" name="Text 1">
+            <a:extLst>
+              <a:ext uri="{FF2B5EF4-FFF2-40B4-BE49-F238E27FC236}">
+                <ns2:creationId id="{2C4FD076-E356-4DE8-8195-3ECF99E05922}"/>
+              </a:ext>
+            </a:extLst>
+          </p:cNvPr>
+          <p:cNvSpPr>
+            <a:spLocks noGrp="1"/>
+          </p:cNvSpPr>
+          <p:nvPr/>
+        </p:nvSpPr>
+        <p:spPr>
+          <a:xfrm>
+            <a:off x="567000" y="274320"/>
+            <a:ext cx="10058040" cy="228240"/>
+          </a:xfrm>
+          <a:prstGeom prst="rect">
+            <a:avLst/>
+          </a:prstGeom>
+          <a:noFill/>
+          <a:ln w="0">
+            <a:noFill/>
+          </a:ln>
+        </p:spPr>
+        <p:style>
+          <a:lnRef idx="0"/>
+          <a:fillRef idx="0"/>
+          <a:effectRef idx="0"/>
+          <a:fontRef idx="minor"/>
+        </p:style>
+        <p:txBody>
+          <a:bodyPr lIns="0" tIns="0" rIns="0" bIns="0" anchor="ctr">
+            <a:normAutofit fontScale="100000"/>
+          </a:bodyPr>
+          <a:lstStyle/>
+          <a:p>
+            <a:pPr defTabSz="914400">
+              <a:lnSpc>
+                <a:spcPct val="100000"/>
+              </a:lnSpc>
+              <a:buNone/>
+              <a:tabLst>
+                <a:tab pos="0" algn="l"/>
+              </a:tabLst>
+            </a:pPr>
+            <a:r>
+              <a:rPr sz="1100" b="1" u="none" strike="noStrike" spc="210">
+                <a:solidFill>
+                  <a:srgbClr val="119F9A"/>
+                </a:solidFill>
+                <a:latin typeface="Aptos"/>
+                <a:ea typeface="Aptos"/>
+                <a:cs typeface="Aptos"/>
+              </a:rPr>
+              <a:t>OUR INSIGHTS</a:t>
+            </a:r>
+            <a:endParaRPr sz="1100" b="0" u="none" strike="noStrike">
+              <a:solidFill>
+                <a:srgbClr val="000000"/>
+              </a:solidFill>
+              <a:latin typeface="Arial"/>
+              <a:ea typeface="Arial"/>
+              <a:cs typeface="Arial"/>
+            </a:endParaRPr>
+          </a:p>
+        </p:txBody>
+      </p:sp>
+      <p:sp>
+        <p:nvSpPr>
+          <p:cNvPr id="3" name="Text 2">
+            <a:extLst>
+              <a:ext uri="{FF2B5EF4-FFF2-40B4-BE49-F238E27FC236}">
+                <ns2:creationId id="{315468C8-12EC-4557-98B5-FDC3DBF2C4F1}"/>
+              </a:ext>
+            </a:extLst>
+          </p:cNvPr>
+          <p:cNvSpPr>
+            <a:spLocks noGrp="1"/>
+          </p:cNvSpPr>
+          <p:nvPr/>
+        </p:nvSpPr>
+        <p:spPr>
+          <a:xfrm>
+            <a:off x="567000" y="621720"/>
+            <a:ext cx="11018160" cy="520920"/>
+          </a:xfrm>
+          <a:prstGeom prst="rect">
+            <a:avLst/>
+          </a:prstGeom>
+          <a:noFill/>
+          <a:ln w="0">
+            <a:noFill/>
+          </a:ln>
+        </p:spPr>
+        <p:style>
+          <a:lnRef idx="0"/>
+          <a:fillRef idx="0"/>
+          <a:effectRef idx="0"/>
+          <a:fontRef idx="minor"/>
+        </p:style>
+        <p:txBody>
+          <a:bodyPr lIns="0" tIns="0" rIns="0" bIns="0" anchor="ctr">
+            <a:normAutofit fontScale="100000"/>
+          </a:bodyPr>
+          <a:lstStyle/>
+          <a:p>
+            <a:pPr defTabSz="914400">
+              <a:lnSpc>
+                <a:spcPct val="100000"/>
+              </a:lnSpc>
+              <a:buNone/>
+              <a:tabLst>
+                <a:tab pos="0" algn="l"/>
+              </a:tabLst>
+            </a:pPr>
+            <a:r>
+              <a:rPr sz="3000" b="1" u="none" strike="noStrike">
+                <a:solidFill>
+                  <a:srgbClr val="14283F"/>
+                </a:solidFill>
+                <a:latin typeface="Aptos"/>
+                <a:ea typeface="Aptos"/>
+                <a:cs typeface="Aptos"/>
+              </a:rPr>
+              <a:t>Critical safety rules need hard enforcement</a:t>
+            </a:r>
+            <a:endParaRPr sz="3000" b="0" u="none" strike="noStrike">
+              <a:solidFill>
+                <a:srgbClr val="000000"/>
+              </a:solidFill>
+              <a:latin typeface="Arial"/>
+              <a:ea typeface="Arial"/>
+              <a:cs typeface="Arial"/>
+            </a:endParaRPr>
+          </a:p>
+        </p:txBody>
+      </p:sp>
+      <p:sp>
+        <p:nvSpPr>
+          <p:cNvPr id="4" name="Shape 3">
+            <a:extLst>
+              <a:ext uri="{FF2B5EF4-FFF2-40B4-BE49-F238E27FC236}">
+                <ns2:creationId id="{F13AF7BF-A49E-4E4F-8D2D-FB40ADA32A60}"/>
+              </a:ext>
+            </a:extLst>
+          </p:cNvPr>
+          <p:cNvSpPr>
+            <a:spLocks noGrp="1"/>
+          </p:cNvSpPr>
+          <p:nvPr/>
+        </p:nvSpPr>
+        <p:spPr>
+          <a:xfrm>
+            <a:off x="566640" y="1280160"/>
+            <a:ext cx="11064240" cy="360"/>
+          </a:xfrm>
+          <a:prstGeom prst="line">
+            <a:avLst/>
+          </a:prstGeom>
+          <a:ln w="12700">
+            <a:solidFill>
+              <a:srgbClr val="DCE5ED"/>
+            </a:solidFill>
+            <a:round/>
+          </a:ln>
+        </p:spPr>
+        <p:style>
+          <a:lnRef idx="0"/>
+          <a:fillRef idx="0"/>
+          <a:effectRef idx="0"/>
+          <a:fontRef idx="minor"/>
+        </p:style>
+        <p:txBody>
+          <a:bodyPr lIns="90000" tIns="-44640" rIns="90000" bIns="-44640" anchor="t">
+            <a:noAutofit/>
+          </a:bodyPr>
+          <a:lstStyle/>
+          <a:p>
+            <a:endParaRPr sz="1800" b="0" u="none" strike="noStrike">
+              <a:solidFill>
+                <a:srgbClr val="000000"/>
+              </a:solidFill>
+              <a:latin typeface="Arial"/>
+              <a:ea typeface="Arial"/>
+              <a:cs typeface="Arial"/>
+            </a:endParaRPr>
+          </a:p>
+        </p:txBody>
+      </p:sp>
+      <p:sp>
+        <p:nvSpPr>
+          <p:cNvPr id="5" name="Shape 4">
+            <a:extLst>
+              <a:ext uri="{FF2B5EF4-FFF2-40B4-BE49-F238E27FC236}">
+                <ns2:creationId id="{189D63D6-788F-49D0-8C5C-EDD51865DA3F}"/>
+              </a:ext>
+            </a:extLst>
+          </p:cNvPr>
+          <p:cNvSpPr>
+            <a:spLocks noGrp="1"/>
+          </p:cNvSpPr>
+          <p:nvPr/>
+        </p:nvSpPr>
+        <p:spPr>
+          <a:xfrm>
+            <a:off x="566640" y="6519600"/>
+            <a:ext cx="11064240" cy="360"/>
+          </a:xfrm>
+          <a:prstGeom prst="line">
+            <a:avLst/>
+          </a:prstGeom>
+          <a:ln w="12700">
+            <a:solidFill>
+              <a:srgbClr val="DCE5ED"/>
+            </a:solidFill>
+            <a:round/>
+          </a:ln>
+        </p:spPr>
+        <p:style>
+          <a:lnRef idx="0"/>
+          <a:fillRef idx="0"/>
+          <a:effectRef idx="0"/>
+          <a:fontRef idx="minor"/>
+        </p:style>
+        <p:txBody>
+          <a:bodyPr lIns="90000" tIns="-44640" rIns="90000" bIns="-44640" anchor="t">
+            <a:noAutofit/>
+          </a:bodyPr>
+          <a:lstStyle/>
+          <a:p>
+            <a:endParaRPr sz="1800" b="0" u="none" strike="noStrike">
+              <a:solidFill>
+                <a:srgbClr val="000000"/>
+              </a:solidFill>
+              <a:latin typeface="Arial"/>
+              <a:ea typeface="Arial"/>
+              <a:cs typeface="Arial"/>
+            </a:endParaRPr>
+          </a:p>
+        </p:txBody>
+      </p:sp>
+      <p:sp>
+        <p:nvSpPr>
+          <p:cNvPr id="6" name="Text 5">
+            <a:extLst>
+              <a:ext uri="{FF2B5EF4-FFF2-40B4-BE49-F238E27FC236}">
+                <ns2:creationId id="{3DE2DF10-865B-4173-A370-EA1BDA3B3EB5}"/>
+              </a:ext>
+            </a:extLst>
+          </p:cNvPr>
+          <p:cNvSpPr>
+            <a:spLocks noGrp="1"/>
+          </p:cNvSpPr>
+          <p:nvPr/>
+        </p:nvSpPr>
+        <p:spPr>
+          <a:xfrm>
+            <a:off x="594360" y="6574680"/>
+            <a:ext cx="10423800" cy="164160"/>
+          </a:xfrm>
+          <a:prstGeom prst="rect">
+            <a:avLst/>
+          </a:prstGeom>
+          <a:noFill/>
+          <a:ln w="0">
+            <a:noFill/>
+          </a:ln>
+        </p:spPr>
+        <p:style>
+          <a:lnRef idx="0"/>
+          <a:fillRef idx="0"/>
+          <a:effectRef idx="0"/>
+          <a:fontRef idx="minor"/>
+        </p:style>
+        <p:txBody>
+          <a:bodyPr lIns="0" tIns="0" rIns="0" bIns="0" anchor="ctr">
+            <a:normAutofit fontScale="100000"/>
+          </a:bodyPr>
+          <a:lstStyle/>
+          <a:p>
+            <a:pPr defTabSz="914400">
+              <a:lnSpc>
+                <a:spcPct val="100000"/>
+              </a:lnSpc>
+              <a:buNone/>
+              <a:tabLst>
+                <a:tab pos="0" algn="l"/>
+              </a:tabLst>
+            </a:pPr>
+            <a:r>
+              <a:rPr sz="860" b="0" u="none" strike="noStrike">
+                <a:solidFill>
+                  <a:srgbClr val="64778B"/>
+                </a:solidFill>
+                <a:latin typeface="Aptos"/>
+                <a:ea typeface="Aptos"/>
+                <a:cs typeface="Aptos"/>
+              </a:rPr>
+              <a:t>Our deployment proposal. Illustrative example, not evaluated in the replication.</a:t>
+            </a:r>
+            <a:endParaRPr sz="860" b="0" u="none" strike="noStrike">
+              <a:solidFill>
+                <a:srgbClr val="000000"/>
+              </a:solidFill>
+              <a:latin typeface="Arial"/>
+              <a:ea typeface="Arial"/>
+              <a:cs typeface="Arial"/>
+            </a:endParaRPr>
+          </a:p>
+        </p:txBody>
+      </p:sp>
+      <p:sp>
+        <p:nvSpPr>
+          <p:cNvPr id="7" name="Text 6">
+            <a:extLst>
+              <a:ext uri="{FF2B5EF4-FFF2-40B4-BE49-F238E27FC236}">
+                <ns2:creationId id="{A05CF2ED-F969-4FF6-9ED9-5A816DB56D30}"/>
+              </a:ext>
+            </a:extLst>
+          </p:cNvPr>
+          <p:cNvSpPr>
+            <a:spLocks noGrp="1"/>
+          </p:cNvSpPr>
+          <p:nvPr/>
+        </p:nvSpPr>
+        <p:spPr>
+          <a:xfrm>
+            <a:off x="11155680" y="6537960"/>
+            <a:ext cx="438480" cy="228240"/>
+          </a:xfrm>
+          <a:prstGeom prst="rect">
+            <a:avLst/>
+          </a:prstGeom>
+          <a:noFill/>
+          <a:ln w="0">
+            <a:noFill/>
+          </a:ln>
+        </p:spPr>
+        <p:style>
+          <a:lnRef idx="0"/>
+          <a:fillRef idx="0"/>
+          <a:effectRef idx="0"/>
+          <a:fontRef idx="minor"/>
+        </p:style>
+        <p:txBody>
+          <a:bodyPr lIns="0" tIns="0" rIns="0" bIns="0" anchor="ctr">
+            <a:normAutofit fontScale="100000"/>
+          </a:bodyPr>
+          <a:lstStyle/>
+          <a:p>
+            <a:pPr algn="r" defTabSz="914400">
+              <a:lnSpc>
+                <a:spcPct val="100000"/>
+              </a:lnSpc>
+              <a:buNone/>
+              <a:tabLst>
+                <a:tab pos="0" algn="l"/>
+              </a:tabLst>
+            </a:pPr>
+            <a:r>
+              <a:rPr sz="1000" b="1" u="none" strike="noStrike">
+                <a:solidFill>
+                  <a:srgbClr val="64778B"/>
+                </a:solidFill>
+                <a:latin typeface="Aptos"/>
+                <a:ea typeface="Aptos"/>
+                <a:cs typeface="Aptos"/>
+              </a:rPr>
+              <a:t>23</a:t>
+            </a:r>
+            <a:endParaRPr sz="1000" b="0" u="none" strike="noStrike">
+              <a:solidFill>
+                <a:srgbClr val="000000"/>
+              </a:solidFill>
+              <a:latin typeface="Arial"/>
+              <a:ea typeface="Arial"/>
+              <a:cs typeface="Arial"/>
+            </a:endParaRPr>
+          </a:p>
+        </p:txBody>
+      </p:sp>
+      <p:sp>
+        <p:nvSpPr>
+          <p:cNvPr id="8" name="">
+            <a:extLst>
+              <a:ext uri="{FF2B5EF4-FFF2-40B4-BE49-F238E27FC236}">
+                <ns2:creationId id="{5756C212-9613-466A-8E25-3915BB9C4F56}"/>
+              </a:ext>
+            </a:extLst>
+          </p:cNvPr>
+          <p:cNvSpPr>
+            <a:spLocks noGrp="1"/>
+          </p:cNvSpPr>
+          <p:nvPr/>
+        </p:nvSpPr>
+        <p:spPr>
+          <a:xfrm>
+            <a:off x="590550" y="1514475"/>
+            <a:ext cx="11010900" cy="723900"/>
+          </a:xfrm>
+          <a:prstGeom prst="rect">
+            <a:avLst/>
+          </a:prstGeom>
+          <a:noFill/>
+          <a:ln w="0">
+            <a:noFill/>
+          </a:ln>
+        </p:spPr>
+        <p:txBody>
+          <a:bodyPr/>
+          <a:lstStyle>
+            <a:defPPr>
+              <a:defRPr sz="2250" b="1">
+                <a:solidFill>
+                  <a:srgbClr val="119F9A"/>
+                </a:solidFill>
+              </a:defRPr>
+            </a:defPPr>
+            <a:lvl1pPr>
+              <a:defRPr sz="2250" b="1">
+                <a:solidFill>
+                  <a:srgbClr val="119F9A"/>
+                </a:solidFill>
+              </a:defRPr>
+            </a:lvl1pPr>
+            <a:lvl2pPr>
+              <a:defRPr sz="2250" b="1">
+                <a:solidFill>
+                  <a:srgbClr val="119F9A"/>
+                </a:solidFill>
+              </a:defRPr>
+            </a:lvl2pPr>
+            <a:lvl3pPr>
+              <a:defRPr sz="2250" b="1">
+                <a:solidFill>
+                  <a:srgbClr val="119F9A"/>
+                </a:solidFill>
+              </a:defRPr>
+            </a:lvl3pPr>
+            <a:lvl4pPr>
+              <a:defRPr sz="2250" b="1">
+                <a:solidFill>
+                  <a:srgbClr val="119F9A"/>
+                </a:solidFill>
+              </a:defRPr>
+            </a:lvl4pPr>
+            <a:lvl5pPr>
+              <a:defRPr sz="2250" b="1">
+                <a:solidFill>
+                  <a:srgbClr val="119F9A"/>
+                </a:solidFill>
+              </a:defRPr>
+            </a:lvl5pPr>
+            <a:lvl6pPr>
+              <a:defRPr sz="2250" b="1">
+                <a:solidFill>
+                  <a:srgbClr val="119F9A"/>
+                </a:solidFill>
+              </a:defRPr>
+            </a:lvl6pPr>
+            <a:lvl7pPr>
+              <a:defRPr sz="2250" b="1">
+                <a:solidFill>
+                  <a:srgbClr val="119F9A"/>
+                </a:solidFill>
+              </a:defRPr>
+            </a:lvl7pPr>
+            <a:lvl8pPr>
+              <a:defRPr sz="2250" b="1">
+                <a:solidFill>
+                  <a:srgbClr val="119F9A"/>
+                </a:solidFill>
+              </a:defRPr>
+            </a:lvl8pPr>
+            <a:lvl9pPr>
+              <a:defRPr sz="2250" b="1">
+                <a:solidFill>
+                  <a:srgbClr val="119F9A"/>
+                </a:solidFill>
+              </a:defRPr>
+            </a:lvl9pPr>
+          </a:lstStyle>
+          <a:p>
+            <a:pPr>
+              <a:defRPr sz="2250" b="1">
+                <a:solidFill>
+                  <a:srgbClr val="119F9A"/>
+                </a:solidFill>
+              </a:defRPr>
+            </a:pPr>
+            <a:r>
+              <a:rPr sz="2250" b="1">
+                <a:solidFill>
+                  <a:srgbClr val="119F9A"/>
+                </a:solidFill>
+              </a:rPr>
+              <a:t>AI interprets intent. An independent safety controller authorizes actions.</a:t>
+            </a:r>
+          </a:p>
+        </p:txBody>
+      </p:sp>
+      <p:sp>
+        <p:nvSpPr>
+          <p:cNvPr id="9" name="">
+            <a:extLst>
+              <a:ext uri="{FF2B5EF4-FFF2-40B4-BE49-F238E27FC236}">
+                <ns2:creationId id="{10BB5BC5-0552-4281-BD6F-CCB2C13A91E1}"/>
+              </a:ext>
+            </a:extLst>
+          </p:cNvPr>
+          <p:cNvSpPr>
+            <a:spLocks noGrp="1"/>
+          </p:cNvSpPr>
+          <p:nvPr/>
+        </p:nvSpPr>
+        <p:spPr>
+          <a:xfrm>
+            <a:off x="590550" y="2476500"/>
+            <a:ext cx="1714500" cy="361950"/>
+          </a:xfrm>
+          <a:prstGeom prst="rect">
+            <a:avLst/>
+          </a:prstGeom>
+          <a:noFill/>
+          <a:ln w="0">
+            <a:noFill/>
+          </a:ln>
+        </p:spPr>
+        <p:txBody>
+          <a:bodyPr/>
+          <a:lstStyle>
+            <a:defPPr>
+              <a:defRPr sz="1800" b="1">
+                <a:solidFill>
+                  <a:srgbClr val="119F9A"/>
+                </a:solidFill>
+              </a:defRPr>
+            </a:defPPr>
+            <a:lvl1pPr>
+              <a:defRPr sz="1800" b="1">
+                <a:solidFill>
+                  <a:srgbClr val="119F9A"/>
+                </a:solidFill>
+              </a:defRPr>
+            </a:lvl1pPr>
+            <a:lvl2pPr>
+              <a:defRPr sz="1800" b="1">
+                <a:solidFill>
+                  <a:srgbClr val="119F9A"/>
+                </a:solidFill>
+              </a:defRPr>
+            </a:lvl2pPr>
+            <a:lvl3pPr>
+              <a:defRPr sz="1800" b="1">
+                <a:solidFill>
+                  <a:srgbClr val="119F9A"/>
+                </a:solidFill>
+              </a:defRPr>
+            </a:lvl3pPr>
+            <a:lvl4pPr>
+              <a:defRPr sz="1800" b="1">
+                <a:solidFill>
+                  <a:srgbClr val="119F9A"/>
+                </a:solidFill>
+              </a:defRPr>
+            </a:lvl4pPr>
+            <a:lvl5pPr>
+              <a:defRPr sz="1800" b="1">
+                <a:solidFill>
+                  <a:srgbClr val="119F9A"/>
+                </a:solidFill>
+              </a:defRPr>
+            </a:lvl5pPr>
+            <a:lvl6pPr>
+              <a:defRPr sz="1800" b="1">
+                <a:solidFill>
+                  <a:srgbClr val="119F9A"/>
+                </a:solidFill>
+              </a:defRPr>
+            </a:lvl6pPr>
+            <a:lvl7pPr>
+              <a:defRPr sz="1800" b="1">
+                <a:solidFill>
+                  <a:srgbClr val="119F9A"/>
+                </a:solidFill>
+              </a:defRPr>
+            </a:lvl7pPr>
+            <a:lvl8pPr>
+              <a:defRPr sz="1800" b="1">
+                <a:solidFill>
+                  <a:srgbClr val="119F9A"/>
+                </a:solidFill>
+              </a:defRPr>
+            </a:lvl8pPr>
+            <a:lvl9pPr>
+              <a:defRPr sz="1800" b="1">
+                <a:solidFill>
+                  <a:srgbClr val="119F9A"/>
+                </a:solidFill>
+              </a:defRPr>
+            </a:lvl9pPr>
+          </a:lstStyle>
+          <a:p>
+            <a:pPr>
+              <a:defRPr sz="1800" b="1">
+                <a:solidFill>
+                  <a:srgbClr val="119F9A"/>
+                </a:solidFill>
+              </a:defRPr>
+            </a:pPr>
+            <a:r>
+              <a:rPr sz="1800" b="1">
+                <a:solidFill>
+                  <a:srgbClr val="119F9A"/>
+                </a:solidFill>
+              </a:rPr>
+              <a:t>WHY</a:t>
+            </a:r>
+          </a:p>
+        </p:txBody>
+      </p:sp>
+      <p:sp>
+        <p:nvSpPr>
+          <p:cNvPr id="10" name="">
+            <a:extLst>
+              <a:ext uri="{FF2B5EF4-FFF2-40B4-BE49-F238E27FC236}">
+                <ns2:creationId id="{4C30EE99-5B5D-42C1-B5CB-7061F6848D6E}"/>
+              </a:ext>
+            </a:extLst>
+          </p:cNvPr>
+          <p:cNvSpPr>
+            <a:spLocks noGrp="1"/>
+          </p:cNvSpPr>
+          <p:nvPr/>
+        </p:nvSpPr>
+        <p:spPr>
+          <a:xfrm>
+            <a:off x="2476500" y="2390775"/>
+            <a:ext cx="9048750" cy="838200"/>
+          </a:xfrm>
+          <a:prstGeom prst="rect">
+            <a:avLst/>
+          </a:prstGeom>
+          <a:noFill/>
+          <a:ln w="0">
+            <a:noFill/>
+          </a:ln>
+        </p:spPr>
+        <p:txBody>
+          <a:bodyPr/>
+          <a:lstStyle>
+            <a:defPPr>
+              <a:defRPr sz="1875" b="0">
+                <a:solidFill>
+                  <a:srgbClr val="14283F"/>
+                </a:solidFill>
+              </a:defRPr>
+            </a:defPPr>
+            <a:lvl1pPr>
+              <a:defRPr sz="1875" b="0">
+                <a:solidFill>
+                  <a:srgbClr val="14283F"/>
+                </a:solidFill>
+              </a:defRPr>
+            </a:lvl1pPr>
+            <a:lvl2pPr>
+              <a:defRPr sz="1875" b="0">
+                <a:solidFill>
+                  <a:srgbClr val="14283F"/>
+                </a:solidFill>
+              </a:defRPr>
+            </a:lvl2pPr>
+            <a:lvl3pPr>
+              <a:defRPr sz="1875" b="0">
+                <a:solidFill>
+                  <a:srgbClr val="14283F"/>
+                </a:solidFill>
+              </a:defRPr>
+            </a:lvl3pPr>
+            <a:lvl4pPr>
+              <a:defRPr sz="1875" b="0">
+                <a:solidFill>
+                  <a:srgbClr val="14283F"/>
+                </a:solidFill>
+              </a:defRPr>
+            </a:lvl4pPr>
+            <a:lvl5pPr>
+              <a:defRPr sz="1875" b="0">
+                <a:solidFill>
+                  <a:srgbClr val="14283F"/>
+                </a:solidFill>
+              </a:defRPr>
+            </a:lvl5pPr>
+            <a:lvl6pPr>
+              <a:defRPr sz="1875" b="0">
+                <a:solidFill>
+                  <a:srgbClr val="14283F"/>
+                </a:solidFill>
+              </a:defRPr>
+            </a:lvl6pPr>
+            <a:lvl7pPr>
+              <a:defRPr sz="1875" b="0">
+                <a:solidFill>
+                  <a:srgbClr val="14283F"/>
+                </a:solidFill>
+              </a:defRPr>
+            </a:lvl7pPr>
+            <a:lvl8pPr>
+              <a:defRPr sz="1875" b="0">
+                <a:solidFill>
+                  <a:srgbClr val="14283F"/>
+                </a:solidFill>
+              </a:defRPr>
+            </a:lvl8pPr>
+            <a:lvl9pPr>
+              <a:defRPr sz="1875" b="0">
+                <a:solidFill>
+                  <a:srgbClr val="14283F"/>
+                </a:solidFill>
+              </a:defRPr>
+            </a:lvl9pPr>
+          </a:lstStyle>
+          <a:p>
+            <a:pPr>
+              <a:defRPr sz="1875" b="0">
+                <a:solidFill>
+                  <a:srgbClr val="14283F"/>
+                </a:solidFill>
+              </a:defRPr>
+            </a:pPr>
+            <a:r>
+              <a:rPr sz="1875" b="0">
+                <a:solidFill>
+                  <a:srgbClr val="14283F"/>
+                </a:solidFill>
+              </a:rPr>
+              <a:t>Even a hypothetical 1% unsafe-action rate is too high to rely on alone.</a:t>
+            </a:r>
+          </a:p>
+          <a:p>
+            <a:pPr>
+              <a:defRPr sz="1875" b="0">
+                <a:solidFill>
+                  <a:srgbClr val="14283F"/>
+                </a:solidFill>
+              </a:defRPr>
+            </a:pPr>
+            <a:r>
+              <a:rPr sz="1875" b="0">
+                <a:solidFill>
+                  <a:srgbClr val="14283F"/>
+                </a:solidFill>
+              </a:rPr>
+              <a:t>Better models do not replace mandatory safety interlocks.</a:t>
+            </a:r>
+          </a:p>
+        </p:txBody>
+      </p:sp>
+      <p:sp>
+        <p:nvSpPr>
+          <p:cNvPr id="11" name="">
+            <a:extLst>
+              <a:ext uri="{FF2B5EF4-FFF2-40B4-BE49-F238E27FC236}">
+                <ns2:creationId id="{2EB3255F-CE76-4A94-BCED-3B69AC68ACF8}"/>
+              </a:ext>
+            </a:extLst>
+          </p:cNvPr>
+          <p:cNvSpPr>
+            <a:spLocks noGrp="1"/>
+          </p:cNvSpPr>
+          <p:nvPr/>
+        </p:nvSpPr>
+        <p:spPr>
+          <a:xfrm>
+            <a:off x="590550" y="3486150"/>
+            <a:ext cx="1714500" cy="361950"/>
+          </a:xfrm>
+          <a:prstGeom prst="rect">
+            <a:avLst/>
+          </a:prstGeom>
+          <a:noFill/>
+          <a:ln w="0">
+            <a:noFill/>
+          </a:ln>
+        </p:spPr>
+        <p:txBody>
+          <a:bodyPr/>
+          <a:lstStyle>
+            <a:defPPr>
+              <a:defRPr sz="1800" b="1">
+                <a:solidFill>
+                  <a:srgbClr val="119F9A"/>
+                </a:solidFill>
+              </a:defRPr>
+            </a:defPPr>
+            <a:lvl1pPr>
+              <a:defRPr sz="1800" b="1">
+                <a:solidFill>
+                  <a:srgbClr val="119F9A"/>
+                </a:solidFill>
+              </a:defRPr>
+            </a:lvl1pPr>
+            <a:lvl2pPr>
+              <a:defRPr sz="1800" b="1">
+                <a:solidFill>
+                  <a:srgbClr val="119F9A"/>
+                </a:solidFill>
+              </a:defRPr>
+            </a:lvl2pPr>
+            <a:lvl3pPr>
+              <a:defRPr sz="1800" b="1">
+                <a:solidFill>
+                  <a:srgbClr val="119F9A"/>
+                </a:solidFill>
+              </a:defRPr>
+            </a:lvl3pPr>
+            <a:lvl4pPr>
+              <a:defRPr sz="1800" b="1">
+                <a:solidFill>
+                  <a:srgbClr val="119F9A"/>
+                </a:solidFill>
+              </a:defRPr>
+            </a:lvl4pPr>
+            <a:lvl5pPr>
+              <a:defRPr sz="1800" b="1">
+                <a:solidFill>
+                  <a:srgbClr val="119F9A"/>
+                </a:solidFill>
+              </a:defRPr>
+            </a:lvl5pPr>
+            <a:lvl6pPr>
+              <a:defRPr sz="1800" b="1">
+                <a:solidFill>
+                  <a:srgbClr val="119F9A"/>
+                </a:solidFill>
+              </a:defRPr>
+            </a:lvl6pPr>
+            <a:lvl7pPr>
+              <a:defRPr sz="1800" b="1">
+                <a:solidFill>
+                  <a:srgbClr val="119F9A"/>
+                </a:solidFill>
+              </a:defRPr>
+            </a:lvl7pPr>
+            <a:lvl8pPr>
+              <a:defRPr sz="1800" b="1">
+                <a:solidFill>
+                  <a:srgbClr val="119F9A"/>
+                </a:solidFill>
+              </a:defRPr>
+            </a:lvl8pPr>
+            <a:lvl9pPr>
+              <a:defRPr sz="1800" b="1">
+                <a:solidFill>
+                  <a:srgbClr val="119F9A"/>
+                </a:solidFill>
+              </a:defRPr>
+            </a:lvl9pPr>
+          </a:lstStyle>
+          <a:p>
+            <a:pPr>
+              <a:defRPr sz="1800" b="1">
+                <a:solidFill>
+                  <a:srgbClr val="119F9A"/>
+                </a:solidFill>
+              </a:defRPr>
+            </a:pPr>
+            <a:r>
+              <a:rPr sz="1800" b="1">
+                <a:solidFill>
+                  <a:srgbClr val="119F9A"/>
+                </a:solidFill>
+              </a:rPr>
+              <a:t>EXAMPLE</a:t>
+            </a:r>
+          </a:p>
+        </p:txBody>
+      </p:sp>
+      <p:sp>
+        <p:nvSpPr>
+          <p:cNvPr id="12" name="">
+            <a:extLst>
+              <a:ext uri="{FF2B5EF4-FFF2-40B4-BE49-F238E27FC236}">
+                <ns2:creationId id="{83644002-A26D-464E-A905-26BA073F82C0}"/>
+              </a:ext>
+            </a:extLst>
+          </p:cNvPr>
+          <p:cNvSpPr>
+            <a:spLocks noGrp="1"/>
+          </p:cNvSpPr>
+          <p:nvPr/>
+        </p:nvSpPr>
+        <p:spPr>
+          <a:xfrm>
+            <a:off x="2476500" y="3400425"/>
+            <a:ext cx="9048750" cy="838200"/>
+          </a:xfrm>
+          <a:prstGeom prst="rect">
+            <a:avLst/>
+          </a:prstGeom>
+          <a:noFill/>
+          <a:ln w="0">
+            <a:noFill/>
+          </a:ln>
+        </p:spPr>
+        <p:txBody>
+          <a:bodyPr/>
+          <a:lstStyle>
+            <a:defPPr>
+              <a:defRPr sz="1875" b="0">
+                <a:solidFill>
+                  <a:srgbClr val="14283F"/>
+                </a:solidFill>
+              </a:defRPr>
+            </a:defPPr>
+            <a:lvl1pPr>
+              <a:defRPr sz="1875" b="0">
+                <a:solidFill>
+                  <a:srgbClr val="14283F"/>
+                </a:solidFill>
+              </a:defRPr>
+            </a:lvl1pPr>
+            <a:lvl2pPr>
+              <a:defRPr sz="1875" b="0">
+                <a:solidFill>
+                  <a:srgbClr val="14283F"/>
+                </a:solidFill>
+              </a:defRPr>
+            </a:lvl2pPr>
+            <a:lvl3pPr>
+              <a:defRPr sz="1875" b="0">
+                <a:solidFill>
+                  <a:srgbClr val="14283F"/>
+                </a:solidFill>
+              </a:defRPr>
+            </a:lvl3pPr>
+            <a:lvl4pPr>
+              <a:defRPr sz="1875" b="0">
+                <a:solidFill>
+                  <a:srgbClr val="14283F"/>
+                </a:solidFill>
+              </a:defRPr>
+            </a:lvl4pPr>
+            <a:lvl5pPr>
+              <a:defRPr sz="1875" b="0">
+                <a:solidFill>
+                  <a:srgbClr val="14283F"/>
+                </a:solidFill>
+              </a:defRPr>
+            </a:lvl5pPr>
+            <a:lvl6pPr>
+              <a:defRPr sz="1875" b="0">
+                <a:solidFill>
+                  <a:srgbClr val="14283F"/>
+                </a:solidFill>
+              </a:defRPr>
+            </a:lvl6pPr>
+            <a:lvl7pPr>
+              <a:defRPr sz="1875" b="0">
+                <a:solidFill>
+                  <a:srgbClr val="14283F"/>
+                </a:solidFill>
+              </a:defRPr>
+            </a:lvl7pPr>
+            <a:lvl8pPr>
+              <a:defRPr sz="1875" b="0">
+                <a:solidFill>
+                  <a:srgbClr val="14283F"/>
+                </a:solidFill>
+              </a:defRPr>
+            </a:lvl8pPr>
+            <a:lvl9pPr>
+              <a:defRPr sz="1875" b="0">
+                <a:solidFill>
+                  <a:srgbClr val="14283F"/>
+                </a:solidFill>
+              </a:defRPr>
+            </a:lvl9pPr>
+          </a:lstStyle>
+          <a:p>
+            <a:pPr>
+              <a:defRPr sz="1875" b="0">
+                <a:solidFill>
+                  <a:srgbClr val="14283F"/>
+                </a:solidFill>
+              </a:defRPr>
+            </a:pPr>
+            <a:r>
+              <a:rPr sz="1875" b="0">
+                <a:solidFill>
+                  <a:srgbClr val="14283F"/>
+                </a:solidFill>
+              </a:rPr>
+              <a:t>Vehicle moving + AI requests powered door release: BLOCK.</a:t>
+            </a:r>
+          </a:p>
+          <a:p>
+            <a:pPr>
+              <a:defRPr sz="1875" b="0">
+                <a:solidFill>
+                  <a:srgbClr val="14283F"/>
+                </a:solidFill>
+              </a:defRPr>
+            </a:pPr>
+            <a:r>
+              <a:rPr sz="1875" b="0">
+                <a:solidFill>
+                  <a:srgbClr val="14283F"/>
+                </a:solidFill>
+              </a:rPr>
+              <a:t>The actuator must reject the command, even if the AI approves it.</a:t>
+            </a:r>
+          </a:p>
+        </p:txBody>
+      </p:sp>
+      <p:sp>
+        <p:nvSpPr>
+          <p:cNvPr id="13" name="">
+            <a:extLst>
+              <a:ext uri="{FF2B5EF4-FFF2-40B4-BE49-F238E27FC236}">
+                <ns2:creationId id="{0137B0CE-FCBD-443B-8DBF-30BB7A13718E}"/>
+              </a:ext>
+            </a:extLst>
+          </p:cNvPr>
+          <p:cNvSpPr>
+            <a:spLocks noGrp="1"/>
+          </p:cNvSpPr>
+          <p:nvPr/>
+        </p:nvSpPr>
+        <p:spPr>
+          <a:xfrm>
+            <a:off x="590550" y="4495800"/>
+            <a:ext cx="1857375" cy="361950"/>
+          </a:xfrm>
+          <a:prstGeom prst="rect">
+            <a:avLst/>
+          </a:prstGeom>
+          <a:noFill/>
+          <a:ln w="0">
+            <a:noFill/>
+          </a:ln>
+        </p:spPr>
+        <p:txBody>
+          <a:bodyPr/>
+          <a:lstStyle>
+            <a:defPPr>
+              <a:defRPr sz="1650" b="1">
+                <a:solidFill>
+                  <a:srgbClr val="119F9A"/>
+                </a:solidFill>
+              </a:defRPr>
+            </a:defPPr>
+            <a:lvl1pPr>
+              <a:defRPr sz="1650" b="1">
+                <a:solidFill>
+                  <a:srgbClr val="119F9A"/>
+                </a:solidFill>
+              </a:defRPr>
+            </a:lvl1pPr>
+            <a:lvl2pPr>
+              <a:defRPr sz="1650" b="1">
+                <a:solidFill>
+                  <a:srgbClr val="119F9A"/>
+                </a:solidFill>
+              </a:defRPr>
+            </a:lvl2pPr>
+            <a:lvl3pPr>
+              <a:defRPr sz="1650" b="1">
+                <a:solidFill>
+                  <a:srgbClr val="119F9A"/>
+                </a:solidFill>
+              </a:defRPr>
+            </a:lvl3pPr>
+            <a:lvl4pPr>
+              <a:defRPr sz="1650" b="1">
+                <a:solidFill>
+                  <a:srgbClr val="119F9A"/>
+                </a:solidFill>
+              </a:defRPr>
+            </a:lvl4pPr>
+            <a:lvl5pPr>
+              <a:defRPr sz="1650" b="1">
+                <a:solidFill>
+                  <a:srgbClr val="119F9A"/>
+                </a:solidFill>
+              </a:defRPr>
+            </a:lvl5pPr>
+            <a:lvl6pPr>
+              <a:defRPr sz="1650" b="1">
+                <a:solidFill>
+                  <a:srgbClr val="119F9A"/>
+                </a:solidFill>
+              </a:defRPr>
+            </a:lvl6pPr>
+            <a:lvl7pPr>
+              <a:defRPr sz="1650" b="1">
+                <a:solidFill>
+                  <a:srgbClr val="119F9A"/>
+                </a:solidFill>
+              </a:defRPr>
+            </a:lvl7pPr>
+            <a:lvl8pPr>
+              <a:defRPr sz="1650" b="1">
+                <a:solidFill>
+                  <a:srgbClr val="119F9A"/>
+                </a:solidFill>
+              </a:defRPr>
+            </a:lvl8pPr>
+            <a:lvl9pPr>
+              <a:defRPr sz="1650" b="1">
+                <a:solidFill>
+                  <a:srgbClr val="119F9A"/>
+                </a:solidFill>
+              </a:defRPr>
+            </a:lvl9pPr>
+          </a:lstStyle>
+          <a:p>
+            <a:pPr>
+              <a:defRPr sz="1650" b="1">
+                <a:solidFill>
+                  <a:srgbClr val="119F9A"/>
+                </a:solidFill>
+              </a:defRPr>
+            </a:pPr>
+            <a:r>
+              <a:rPr sz="1650" b="1">
+                <a:solidFill>
+                  <a:srgbClr val="119F9A"/>
+                </a:solidFill>
+              </a:rPr>
+              <a:t>ENFORCEMENT</a:t>
+            </a:r>
+          </a:p>
+        </p:txBody>
+      </p:sp>
+      <p:sp>
+        <p:nvSpPr>
+          <p:cNvPr id="14" name="">
+            <a:extLst>
+              <a:ext uri="{FF2B5EF4-FFF2-40B4-BE49-F238E27FC236}">
+                <ns2:creationId id="{AE5DD7D1-CD66-4BE4-A289-A8C537C81AE5}"/>
+              </a:ext>
+            </a:extLst>
+          </p:cNvPr>
+          <p:cNvSpPr>
+            <a:spLocks noGrp="1"/>
+          </p:cNvSpPr>
+          <p:nvPr/>
+        </p:nvSpPr>
+        <p:spPr>
+          <a:xfrm>
+            <a:off x="2476500" y="4410075"/>
+            <a:ext cx="9048750" cy="838200"/>
+          </a:xfrm>
+          <a:prstGeom prst="rect">
+            <a:avLst/>
+          </a:prstGeom>
+          <a:noFill/>
+          <a:ln w="0">
+            <a:noFill/>
+          </a:ln>
+        </p:spPr>
+        <p:txBody>
+          <a:bodyPr/>
+          <a:lstStyle>
+            <a:defPPr>
+              <a:defRPr sz="1875" b="0">
+                <a:solidFill>
+                  <a:srgbClr val="14283F"/>
+                </a:solidFill>
+              </a:defRPr>
+            </a:defPPr>
+            <a:lvl1pPr>
+              <a:defRPr sz="1875" b="0">
+                <a:solidFill>
+                  <a:srgbClr val="14283F"/>
+                </a:solidFill>
+              </a:defRPr>
+            </a:lvl1pPr>
+            <a:lvl2pPr>
+              <a:defRPr sz="1875" b="0">
+                <a:solidFill>
+                  <a:srgbClr val="14283F"/>
+                </a:solidFill>
+              </a:defRPr>
+            </a:lvl2pPr>
+            <a:lvl3pPr>
+              <a:defRPr sz="1875" b="0">
+                <a:solidFill>
+                  <a:srgbClr val="14283F"/>
+                </a:solidFill>
+              </a:defRPr>
+            </a:lvl3pPr>
+            <a:lvl4pPr>
+              <a:defRPr sz="1875" b="0">
+                <a:solidFill>
+                  <a:srgbClr val="14283F"/>
+                </a:solidFill>
+              </a:defRPr>
+            </a:lvl4pPr>
+            <a:lvl5pPr>
+              <a:defRPr sz="1875" b="0">
+                <a:solidFill>
+                  <a:srgbClr val="14283F"/>
+                </a:solidFill>
+              </a:defRPr>
+            </a:lvl5pPr>
+            <a:lvl6pPr>
+              <a:defRPr sz="1875" b="0">
+                <a:solidFill>
+                  <a:srgbClr val="14283F"/>
+                </a:solidFill>
+              </a:defRPr>
+            </a:lvl6pPr>
+            <a:lvl7pPr>
+              <a:defRPr sz="1875" b="0">
+                <a:solidFill>
+                  <a:srgbClr val="14283F"/>
+                </a:solidFill>
+              </a:defRPr>
+            </a:lvl7pPr>
+            <a:lvl8pPr>
+              <a:defRPr sz="1875" b="0">
+                <a:solidFill>
+                  <a:srgbClr val="14283F"/>
+                </a:solidFill>
+              </a:defRPr>
+            </a:lvl8pPr>
+            <a:lvl9pPr>
+              <a:defRPr sz="1875" b="0">
+                <a:solidFill>
+                  <a:srgbClr val="14283F"/>
+                </a:solidFill>
+              </a:defRPr>
+            </a:lvl9pPr>
+          </a:lstStyle>
+          <a:p>
+            <a:pPr>
+              <a:defRPr sz="1875" b="0">
+                <a:solidFill>
+                  <a:srgbClr val="14283F"/>
+                </a:solidFill>
+              </a:defRPr>
+            </a:pPr>
+            <a:r>
+              <a:rPr sz="1875" b="0">
+                <a:solidFill>
+                  <a:srgbClr val="14283F"/>
+                </a:solidFill>
+              </a:rPr>
+              <a:t>Encode critical policies as fixed, tested rules outside the model.</a:t>
+            </a:r>
+          </a:p>
+          <a:p>
+            <a:pPr>
+              <a:defRPr sz="1875" b="0">
+                <a:solidFill>
+                  <a:srgbClr val="14283F"/>
+                </a:solidFill>
+              </a:defRPr>
+            </a:pPr>
+            <a:r>
+              <a:rPr sz="1875" b="0">
+                <a:solidFill>
+                  <a:srgbClr val="14283F"/>
+                </a:solidFill>
+              </a:rPr>
+              <a:t>Use trusted vehicle state. Give the AI no bypass.</a:t>
+            </a:r>
+          </a:p>
+        </p:txBody>
+      </p:sp>
+      <p:sp>
+        <p:nvSpPr>
+          <p:cNvPr id="15" name="">
+            <a:extLst>
+              <a:ext uri="{FF2B5EF4-FFF2-40B4-BE49-F238E27FC236}">
+                <ns2:creationId id="{DBC61CB3-F3E5-4548-94F7-B2ACCCEF4C7F}"/>
+              </a:ext>
+            </a:extLst>
+          </p:cNvPr>
+          <p:cNvSpPr>
+            <a:spLocks noGrp="1"/>
+          </p:cNvSpPr>
+          <p:nvPr/>
+        </p:nvSpPr>
+        <p:spPr>
+          <a:xfrm>
+            <a:off x="590550" y="5410200"/>
+            <a:ext cx="11010900" cy="333375"/>
+          </a:xfrm>
+          <a:prstGeom prst="rect">
+            <a:avLst/>
+          </a:prstGeom>
+          <a:noFill/>
+          <a:ln w="0">
+            <a:noFill/>
+          </a:ln>
+        </p:spPr>
+        <p:txBody>
+          <a:bodyPr/>
+          <a:lstStyle>
+            <a:defPPr>
+              <a:defRPr sz="1575" b="0">
+                <a:solidFill>
+                  <a:srgbClr val="607892"/>
+                </a:solidFill>
+              </a:defRPr>
+            </a:defPPr>
+            <a:lvl1pPr>
+              <a:defRPr sz="1575" b="0">
+                <a:solidFill>
+                  <a:srgbClr val="607892"/>
+                </a:solidFill>
+              </a:defRPr>
+            </a:lvl1pPr>
+            <a:lvl2pPr>
+              <a:defRPr sz="1575" b="0">
+                <a:solidFill>
+                  <a:srgbClr val="607892"/>
+                </a:solidFill>
+              </a:defRPr>
+            </a:lvl2pPr>
+            <a:lvl3pPr>
+              <a:defRPr sz="1575" b="0">
+                <a:solidFill>
+                  <a:srgbClr val="607892"/>
+                </a:solidFill>
+              </a:defRPr>
+            </a:lvl3pPr>
+            <a:lvl4pPr>
+              <a:defRPr sz="1575" b="0">
+                <a:solidFill>
+                  <a:srgbClr val="607892"/>
+                </a:solidFill>
+              </a:defRPr>
+            </a:lvl4pPr>
+            <a:lvl5pPr>
+              <a:defRPr sz="1575" b="0">
+                <a:solidFill>
+                  <a:srgbClr val="607892"/>
+                </a:solidFill>
+              </a:defRPr>
+            </a:lvl5pPr>
+            <a:lvl6pPr>
+              <a:defRPr sz="1575" b="0">
+                <a:solidFill>
+                  <a:srgbClr val="607892"/>
+                </a:solidFill>
+              </a:defRPr>
+            </a:lvl6pPr>
+            <a:lvl7pPr>
+              <a:defRPr sz="1575" b="0">
+                <a:solidFill>
+                  <a:srgbClr val="607892"/>
+                </a:solidFill>
+              </a:defRPr>
+            </a:lvl7pPr>
+            <a:lvl8pPr>
+              <a:defRPr sz="1575" b="0">
+                <a:solidFill>
+                  <a:srgbClr val="607892"/>
+                </a:solidFill>
+              </a:defRPr>
+            </a:lvl8pPr>
+            <a:lvl9pPr>
+              <a:defRPr sz="1575" b="0">
+                <a:solidFill>
+                  <a:srgbClr val="607892"/>
+                </a:solidFill>
+              </a:defRPr>
+            </a:lvl9pPr>
+          </a:lstStyle>
+          <a:p>
+            <a:pPr>
+              <a:defRPr sz="1575" b="0">
+                <a:solidFill>
+                  <a:srgbClr val="607892"/>
+                </a:solidFill>
+              </a:defRPr>
+            </a:pPr>
+            <a:r>
+              <a:rPr sz="1575" b="0">
+                <a:solidFill>
+                  <a:srgbClr val="607892"/>
+                </a:solidFill>
+              </a:rPr>
+              <a:t>Emergency egress requires a separately engineered safety path.</a:t>
+            </a:r>
+          </a:p>
+        </p:txBody>
+      </p:sp>
+      <p:sp>
+        <p:nvSpPr>
+          <p:cNvPr id="16" name="">
+            <a:extLst>
+              <a:ext uri="{FF2B5EF4-FFF2-40B4-BE49-F238E27FC236}">
+                <ns2:creationId id="{2A163987-A358-4010-9389-2850A1118386}"/>
+              </a:ext>
+            </a:extLst>
+          </p:cNvPr>
+          <p:cNvSpPr>
+            <a:spLocks noGrp="1"/>
+          </p:cNvSpPr>
+          <p:nvPr/>
+        </p:nvSpPr>
+        <p:spPr>
+          <a:xfrm>
+            <a:off x="590550" y="5915025"/>
+            <a:ext cx="4095750" cy="333375"/>
+          </a:xfrm>
+          <a:prstGeom prst="rect">
+            <a:avLst/>
+          </a:prstGeom>
+          <a:noFill/>
+          <a:ln w="0">
+            <a:noFill/>
+          </a:ln>
+        </p:spPr>
+        <p:txBody>
+          <a:bodyPr/>
+          <a:lstStyle>
+            <a:defPPr>
+              <a:defRPr sz="1725" b="1">
+                <a:solidFill>
+                  <a:srgbClr val="119F9A"/>
+                </a:solidFill>
+              </a:defRPr>
+            </a:defPPr>
+            <a:lvl1pPr>
+              <a:defRPr sz="1725" b="1">
+                <a:solidFill>
+                  <a:srgbClr val="119F9A"/>
+                </a:solidFill>
+              </a:defRPr>
+            </a:lvl1pPr>
+            <a:lvl2pPr>
+              <a:defRPr sz="1725" b="1">
+                <a:solidFill>
+                  <a:srgbClr val="119F9A"/>
+                </a:solidFill>
+              </a:defRPr>
+            </a:lvl2pPr>
+            <a:lvl3pPr>
+              <a:defRPr sz="1725" b="1">
+                <a:solidFill>
+                  <a:srgbClr val="119F9A"/>
+                </a:solidFill>
+              </a:defRPr>
+            </a:lvl3pPr>
+            <a:lvl4pPr>
+              <a:defRPr sz="1725" b="1">
+                <a:solidFill>
+                  <a:srgbClr val="119F9A"/>
+                </a:solidFill>
+              </a:defRPr>
+            </a:lvl4pPr>
+            <a:lvl5pPr>
+              <a:defRPr sz="1725" b="1">
+                <a:solidFill>
+                  <a:srgbClr val="119F9A"/>
+                </a:solidFill>
+              </a:defRPr>
+            </a:lvl5pPr>
+            <a:lvl6pPr>
+              <a:defRPr sz="1725" b="1">
+                <a:solidFill>
+                  <a:srgbClr val="119F9A"/>
+                </a:solidFill>
+              </a:defRPr>
+            </a:lvl6pPr>
+            <a:lvl7pPr>
+              <a:defRPr sz="1725" b="1">
+                <a:solidFill>
+                  <a:srgbClr val="119F9A"/>
+                </a:solidFill>
+              </a:defRPr>
+            </a:lvl7pPr>
+            <a:lvl8pPr>
+              <a:defRPr sz="1725" b="1">
+                <a:solidFill>
+                  <a:srgbClr val="119F9A"/>
+                </a:solidFill>
+              </a:defRPr>
+            </a:lvl8pPr>
+            <a:lvl9pPr>
+              <a:defRPr sz="1725" b="1">
+                <a:solidFill>
+                  <a:srgbClr val="119F9A"/>
+                </a:solidFill>
+              </a:defRPr>
+            </a:lvl9pPr>
+          </a:lstStyle>
+          <a:p>
+            <a:pPr>
+              <a:defRPr sz="1725" b="1">
+                <a:solidFill>
+                  <a:srgbClr val="119F9A"/>
+                </a:solidFill>
+              </a:defRPr>
+            </a:pPr>
+            <a:r>
+              <a:rPr sz="1725" b="1" u="sng">
+                <a:solidFill>
+                  <a:srgbClr val="119F9A"/>
+                </a:solidFill>
+                <a:hlinkClick r:id="rIdSafetyLink0"/>
+              </a:rPr>
+              <a:t>Reproduction repository</a:t>
+            </a:r>
+          </a:p>
+        </p:txBody>
+      </p:sp>
+      <p:sp>
+        <p:nvSpPr>
+          <p:cNvPr id="17" name="">
+            <a:extLst>
+              <a:ext uri="{FF2B5EF4-FFF2-40B4-BE49-F238E27FC236}">
+                <ns2:creationId id="{62C601C8-9A86-4ACB-9988-BA797DBA82F6}"/>
+              </a:ext>
+            </a:extLst>
+          </p:cNvPr>
+          <p:cNvSpPr>
+            <a:spLocks noGrp="1"/>
+          </p:cNvSpPr>
+          <p:nvPr/>
+        </p:nvSpPr>
+        <p:spPr>
+          <a:xfrm>
+            <a:off x="5095875" y="5915025"/>
+            <a:ext cx="3333750" cy="333375"/>
+          </a:xfrm>
+          <a:prstGeom prst="rect">
+            <a:avLst/>
+          </a:prstGeom>
+          <a:noFill/>
+          <a:ln w="0">
+            <a:noFill/>
+          </a:ln>
+        </p:spPr>
+        <p:txBody>
+          <a:bodyPr/>
+          <a:lstStyle>
+            <a:defPPr>
+              <a:defRPr sz="1725" b="1">
+                <a:solidFill>
+                  <a:srgbClr val="119F9A"/>
+                </a:solidFill>
+              </a:defRPr>
+            </a:defPPr>
+            <a:lvl1pPr>
+              <a:defRPr sz="1725" b="1">
+                <a:solidFill>
+                  <a:srgbClr val="119F9A"/>
+                </a:solidFill>
+              </a:defRPr>
+            </a:lvl1pPr>
+            <a:lvl2pPr>
+              <a:defRPr sz="1725" b="1">
+                <a:solidFill>
+                  <a:srgbClr val="119F9A"/>
+                </a:solidFill>
+              </a:defRPr>
+            </a:lvl2pPr>
+            <a:lvl3pPr>
+              <a:defRPr sz="1725" b="1">
+                <a:solidFill>
+                  <a:srgbClr val="119F9A"/>
+                </a:solidFill>
+              </a:defRPr>
+            </a:lvl3pPr>
+            <a:lvl4pPr>
+              <a:defRPr sz="1725" b="1">
+                <a:solidFill>
+                  <a:srgbClr val="119F9A"/>
+                </a:solidFill>
+              </a:defRPr>
+            </a:lvl4pPr>
+            <a:lvl5pPr>
+              <a:defRPr sz="1725" b="1">
+                <a:solidFill>
+                  <a:srgbClr val="119F9A"/>
+                </a:solidFill>
+              </a:defRPr>
+            </a:lvl5pPr>
+            <a:lvl6pPr>
+              <a:defRPr sz="1725" b="1">
+                <a:solidFill>
+                  <a:srgbClr val="119F9A"/>
+                </a:solidFill>
+              </a:defRPr>
+            </a:lvl6pPr>
+            <a:lvl7pPr>
+              <a:defRPr sz="1725" b="1">
+                <a:solidFill>
+                  <a:srgbClr val="119F9A"/>
+                </a:solidFill>
+              </a:defRPr>
+            </a:lvl7pPr>
+            <a:lvl8pPr>
+              <a:defRPr sz="1725" b="1">
+                <a:solidFill>
+                  <a:srgbClr val="119F9A"/>
+                </a:solidFill>
+              </a:defRPr>
+            </a:lvl8pPr>
+            <a:lvl9pPr>
+              <a:defRPr sz="1725" b="1">
+                <a:solidFill>
+                  <a:srgbClr val="119F9A"/>
+                </a:solidFill>
+              </a:defRPr>
+            </a:lvl9pPr>
+          </a:lstStyle>
+          <a:p>
+            <a:pPr>
+              <a:defRPr sz="1725" b="1">
+                <a:solidFill>
+                  <a:srgbClr val="119F9A"/>
+                </a:solidFill>
+              </a:defRPr>
+            </a:pPr>
+            <a:r>
+              <a:rPr sz="1725" b="1" u="sng">
+                <a:solidFill>
+                  <a:srgbClr val="119F9A"/>
+                </a:solidFill>
+                <a:hlinkClick r:id="rIdSafetyLink1"/>
+              </a:rPr>
+              <a:t>Full English report</a:t>
+            </a:r>
+          </a:p>
+        </p:txBody>
+      </p:sp>
+      <p:sp>
+        <p:nvSpPr>
+          <p:cNvPr id="18" name="">
+            <a:extLst>
+              <a:ext uri="{FF2B5EF4-FFF2-40B4-BE49-F238E27FC236}">
+                <ns2:creationId id="{CE15B3E8-987C-4A01-978B-9070DC238CFB}"/>
+              </a:ext>
+            </a:extLst>
+          </p:cNvPr>
+          <p:cNvSpPr>
+            <a:spLocks noGrp="1"/>
+          </p:cNvSpPr>
+          <p:nvPr/>
+        </p:nvSpPr>
+        <p:spPr>
+          <a:xfrm>
+            <a:off x="9115425" y="5943600"/>
+            <a:ext cx="2476500" cy="304800"/>
+          </a:xfrm>
+          <a:prstGeom prst="rect">
+            <a:avLst/>
+          </a:prstGeom>
+          <a:noFill/>
+          <a:ln w="0">
+            <a:noFill/>
+          </a:ln>
+        </p:spPr>
+        <p:txBody>
+          <a:bodyPr/>
+          <a:lstStyle>
+            <a:defPPr>
+              <a:defRPr sz="1275" b="0">
+                <a:solidFill>
+                  <a:srgbClr val="607892"/>
+                </a:solidFill>
+              </a:defRPr>
+            </a:defPPr>
+            <a:lvl1pPr>
+              <a:defRPr sz="1275" b="0">
+                <a:solidFill>
+                  <a:srgbClr val="607892"/>
+                </a:solidFill>
+              </a:defRPr>
+            </a:lvl1pPr>
+            <a:lvl2pPr>
+              <a:defRPr sz="1275" b="0">
+                <a:solidFill>
+                  <a:srgbClr val="607892"/>
+                </a:solidFill>
+              </a:defRPr>
+            </a:lvl2pPr>
+            <a:lvl3pPr>
+              <a:defRPr sz="1275" b="0">
+                <a:solidFill>
+                  <a:srgbClr val="607892"/>
+                </a:solidFill>
+              </a:defRPr>
+            </a:lvl3pPr>
+            <a:lvl4pPr>
+              <a:defRPr sz="1275" b="0">
+                <a:solidFill>
+                  <a:srgbClr val="607892"/>
+                </a:solidFill>
+              </a:defRPr>
+            </a:lvl4pPr>
+            <a:lvl5pPr>
+              <a:defRPr sz="1275" b="0">
+                <a:solidFill>
+                  <a:srgbClr val="607892"/>
+                </a:solidFill>
+              </a:defRPr>
+            </a:lvl5pPr>
+            <a:lvl6pPr>
+              <a:defRPr sz="1275" b="0">
+                <a:solidFill>
+                  <a:srgbClr val="607892"/>
+                </a:solidFill>
+              </a:defRPr>
+            </a:lvl6pPr>
+            <a:lvl7pPr>
+              <a:defRPr sz="1275" b="0">
+                <a:solidFill>
+                  <a:srgbClr val="607892"/>
+                </a:solidFill>
+              </a:defRPr>
+            </a:lvl7pPr>
+            <a:lvl8pPr>
+              <a:defRPr sz="1275" b="0">
+                <a:solidFill>
+                  <a:srgbClr val="607892"/>
+                </a:solidFill>
+              </a:defRPr>
+            </a:lvl8pPr>
+            <a:lvl9pPr>
+              <a:defRPr sz="1275" b="0">
+                <a:solidFill>
+                  <a:srgbClr val="607892"/>
+                </a:solidFill>
+              </a:defRPr>
+            </a:lvl9pPr>
+          </a:lstStyle>
+          <a:p>
+            <a:pPr>
+              <a:defRPr sz="1275" b="0">
+                <a:solidFill>
+                  <a:srgbClr val="607892"/>
+                </a:solidFill>
+              </a:defRPr>
+            </a:pPr>
+            <a:r>
+              <a:rPr sz="1275" b="0">
+                <a:solidFill>
+                  <a:srgbClr val="607892"/>
+                </a:solidFill>
+              </a:rPr>
+              <a:t>GitHub access required</a:t>
+            </a:r>
+          </a:p>
+        </p:txBody>
+      </p:sp>
+    </p:spTree>
+    <p:extLst>
+      <p:ext uri="{BB962C8B-B14F-4D97-AF65-F5344CB8AC3E}">
+        <ns4:creationId val="1374121144"/>
       </p:ext>
     </p:extLst>
   </p:cSld>

</xml_diff>